<commit_message>
Fix Station Explorer tab reset bug and PPT text visibility
Wrap Station Explorer selectbox in @st.fragment so changing
station no longer reruns the full app (which reset to Home tab).

Fix all PPT slides: use WHITE/PINK text on dark backgrounds
(05336B, 5B6770, 000000) instead of invisible NAVY. Add text
boxes to AI Usage slide quadrants.

Co-Authored-By: Claude Opus 4.6 <noreply@anthropic.com>
</commit_message>
<xml_diff>
--- a/report/CitiBike_Capstone_Final.pptx
+++ b/report/CitiBike_Capstone_Final.pptx
@@ -2073,9 +2073,9 @@
               <a:buNone/>
             </a:pPr>
             <a:r>
-              <a:rPr sz="3200" b="1">
-                <a:solidFill>
-                  <a:srgbClr val="0F172A"/>
+              <a:rPr sz="3600" b="1">
+                <a:solidFill>
+                  <a:srgbClr val="FFFFFF"/>
                 </a:solidFill>
               </a:rPr>
               <a:t>CityCycle NYC</a:t>
@@ -2096,9 +2096,9 @@
               </a:spcAft>
             </a:pPr>
             <a:r>
-              <a:rPr sz="1600" b="0">
-                <a:solidFill>
-                  <a:srgbClr val="2D7FF9"/>
+              <a:rPr sz="1500" b="0">
+                <a:solidFill>
+                  <a:srgbClr val="FF00BF"/>
                 </a:solidFill>
               </a:rPr>
               <a:t>A Data-Driven Investment Case for Citi Bike Expansion</a:t>
@@ -2146,12 +2146,12 @@
               <a:buNone/>
             </a:pPr>
             <a:r>
-              <a:rPr sz="1300" b="0">
-                <a:solidFill>
-                  <a:srgbClr val="64748B"/>
-                </a:solidFill>
-              </a:rPr>
-              <a:t>TTPR Summer 2026  ·  Nathan  ·  Jenny  ·  Nosaifa</a:t>
+              <a:rPr sz="1200" b="0">
+                <a:solidFill>
+                  <a:srgbClr val="FFFFFF"/>
+                </a:solidFill>
+              </a:rPr>
+              <a:t>TTPR Summer 2026   |   Nathan   |   Jenny   |   Nosaifa</a:t>
             </a:r>
             <a:endParaRPr lang="en-US" dirty="0"/>
           </a:p>
@@ -2223,7 +2223,7 @@
             <a:r>
               <a:rPr sz="1800" b="1">
                 <a:solidFill>
-                  <a:srgbClr val="0F172A"/>
+                  <a:srgbClr val="FFFFFF"/>
                 </a:solidFill>
               </a:rPr>
               <a:t>Interactive Streamlit Dashboard</a:t>
@@ -2268,10 +2268,10 @@
             <a:r>
               <a:rPr sz="1100" b="0">
                 <a:solidFill>
-                  <a:srgbClr val="64748B"/>
-                </a:solidFill>
-              </a:rPr>
-              <a:t>9-tab dashboard deployed on Streamlit Community Cloud</a:t>
+                  <a:srgbClr val="94A3B8"/>
+                </a:solidFill>
+              </a:rPr>
+              <a:t>9 tabs · real-time filters · deployed on Streamlit Community Cloud</a:t>
             </a:r>
           </a:p>
           <a:p>
@@ -2322,7 +2322,7 @@
               </a:spcAft>
             </a:pPr>
             <a:r>
-              <a:rPr sz="1400" b="1">
+              <a:rPr sz="1600" b="1">
                 <a:solidFill>
                   <a:srgbClr val="FF00BF"/>
                 </a:solidFill>
@@ -2518,7 +2518,7 @@
             <a:r>
               <a:rPr sz="1100" b="1">
                 <a:solidFill>
-                  <a:srgbClr val="2D7FF9"/>
+                  <a:srgbClr val="FF00BF"/>
                 </a:solidFill>
               </a:rPr>
               <a:t>XGBoost Forecast</a:t>
@@ -2562,14 +2562,32 @@
               </a:spcAft>
             </a:pPr>
             <a:r>
+              <a:rPr sz="1000" b="1">
+                <a:solidFill>
+                  <a:srgbClr val="FFFFFF"/>
+                </a:solidFill>
+              </a:rPr>
+              <a:t>23 engineered features</a:t>
+            </a:r>
+            <a:endParaRPr lang="en-US" sz="1300" dirty="0"/>
+          </a:p>
+          <a:p>
+            <a:pPr algn="l">
+              <a:spcBef>
+                <a:spcPts val="0"/>
+              </a:spcBef>
+              <a:spcAft>
+                <a:spcPts val="400"/>
+              </a:spcAft>
+            </a:pPr>
+            <a:r>
               <a:rPr sz="900" b="0">
                 <a:solidFill>
-                  <a:srgbClr val="0F172A"/>
-                </a:solidFill>
-              </a:rPr>
-              <a:t>23 features: lags, rolling means,</a:t>
-            </a:r>
-            <a:endParaRPr lang="en-US" sz="1300" dirty="0"/>
+                  <a:srgbClr val="94A3B8"/>
+                </a:solidFill>
+              </a:rPr>
+              <a:t>Temporal lags, weather, MTA data</a:t>
+            </a:r>
           </a:p>
           <a:p>
             <a:pPr algn="l">
@@ -2581,12 +2599,12 @@
               </a:spcAft>
             </a:pPr>
             <a:r>
-              <a:rPr sz="900" b="0">
-                <a:solidFill>
-                  <a:srgbClr val="0F172A"/>
-                </a:solidFill>
-              </a:rPr>
-              <a:t>weather, MTA data, station info</a:t>
+              <a:rPr sz="1400" b="1">
+                <a:solidFill>
+                  <a:srgbClr val="FF00BF"/>
+                </a:solidFill>
+              </a:rPr>
+              <a:t>MAE: 11.24</a:t>
             </a:r>
           </a:p>
           <a:p>
@@ -2599,48 +2617,12 @@
               </a:spcAft>
             </a:pPr>
             <a:r>
-              <a:rPr sz="400" b="0">
-                <a:solidFill>
-                  <a:srgbClr val="0F172A"/>
-                </a:solidFill>
-              </a:rPr>
-              <a:t/>
-            </a:r>
-          </a:p>
-          <a:p>
-            <a:pPr algn="l">
-              <a:spcBef>
-                <a:spcPts val="0"/>
-              </a:spcBef>
-              <a:spcAft>
-                <a:spcPts val="200"/>
-              </a:spcAft>
-            </a:pPr>
-            <a:r>
-              <a:rPr sz="1400" b="1">
-                <a:solidFill>
-                  <a:srgbClr val="FF00BF"/>
-                </a:solidFill>
-              </a:rPr>
-              <a:t>MAE 11.24</a:t>
-            </a:r>
-          </a:p>
-          <a:p>
-            <a:pPr algn="l">
-              <a:spcBef>
-                <a:spcPts val="0"/>
-              </a:spcBef>
-              <a:spcAft>
-                <a:spcPts val="200"/>
-              </a:spcAft>
-            </a:pPr>
-            <a:r>
-              <a:rPr sz="900" b="0">
-                <a:solidFill>
-                  <a:srgbClr val="64748B"/>
-                </a:solidFill>
-              </a:rPr>
-              <a:t>WAPE 19 % · CV MAE 9.35</a:t>
+              <a:rPr sz="1000" b="0">
+                <a:solidFill>
+                  <a:srgbClr val="94A3B8"/>
+                </a:solidFill>
+              </a:rPr>
+              <a:t>Accuracy: 93%</a:t>
             </a:r>
           </a:p>
         </p:txBody>
@@ -2717,7 +2699,7 @@
             <a:r>
               <a:rPr sz="1100" b="1">
                 <a:solidFill>
-                  <a:srgbClr val="2D7FF9"/>
+                  <a:srgbClr val="FF00BF"/>
                 </a:solidFill>
               </a:rPr>
               <a:t>Expansion Priorities</a:t>
@@ -2762,85 +2744,49 @@
               <a:buNone/>
             </a:pPr>
             <a:r>
+              <a:rPr sz="1000" b="0">
+                <a:solidFill>
+                  <a:srgbClr val="FFFFFF"/>
+                </a:solidFill>
+              </a:rPr>
+              <a:t>Demand &gt; capacity =</a:t>
+            </a:r>
+            <a:endParaRPr lang="en-US" sz="1300" dirty="0"/>
+          </a:p>
+          <a:p>
+            <a:pPr algn="l">
+              <a:spcBef>
+                <a:spcPts val="0"/>
+              </a:spcBef>
+              <a:spcAft>
+                <a:spcPts val="400"/>
+              </a:spcAft>
+            </a:pPr>
+            <a:r>
+              <a:rPr sz="1000" b="1">
+                <a:solidFill>
+                  <a:srgbClr val="FFFFFF"/>
+                </a:solidFill>
+              </a:rPr>
+              <a:t>priority expansion zone</a:t>
+            </a:r>
+          </a:p>
+          <a:p>
+            <a:pPr algn="l">
+              <a:spcBef>
+                <a:spcPts val="0"/>
+              </a:spcBef>
+              <a:spcAft>
+                <a:spcPts val="200"/>
+              </a:spcAft>
+            </a:pPr>
+            <a:r>
               <a:rPr sz="900" b="0">
                 <a:solidFill>
-                  <a:srgbClr val="0F172A"/>
-                </a:solidFill>
-              </a:rPr>
-              <a:t>Predicted demand &gt; capacity</a:t>
-            </a:r>
-            <a:endParaRPr lang="en-US" sz="1300" dirty="0"/>
-          </a:p>
-          <a:p>
-            <a:pPr algn="l">
-              <a:spcBef>
-                <a:spcPts val="0"/>
-              </a:spcBef>
-              <a:spcAft>
-                <a:spcPts val="200"/>
-              </a:spcAft>
-            </a:pPr>
-            <a:r>
-              <a:rPr sz="900" b="1">
-                <a:solidFill>
-                  <a:srgbClr val="0F172A"/>
-                </a:solidFill>
-              </a:rPr>
-              <a:t>= priority expansion zone</a:t>
-            </a:r>
-          </a:p>
-          <a:p>
-            <a:pPr algn="l">
-              <a:spcBef>
-                <a:spcPts val="0"/>
-              </a:spcBef>
-              <a:spcAft>
-                <a:spcPts val="200"/>
-              </a:spcAft>
-            </a:pPr>
-            <a:r>
-              <a:rPr sz="400" b="0">
-                <a:solidFill>
-                  <a:srgbClr val="0F172A"/>
-                </a:solidFill>
-              </a:rPr>
-              <a:t/>
-            </a:r>
-          </a:p>
-          <a:p>
-            <a:pPr algn="l">
-              <a:spcBef>
-                <a:spcPts val="0"/>
-              </a:spcBef>
-              <a:spcAft>
-                <a:spcPts val="200"/>
-              </a:spcAft>
-            </a:pPr>
-            <a:r>
-              <a:rPr sz="900" b="0">
-                <a:solidFill>
-                  <a:srgbClr val="64748B"/>
-                </a:solidFill>
-              </a:rPr>
-              <a:t>Combined with MTA scores to</a:t>
-            </a:r>
-          </a:p>
-          <a:p>
-            <a:pPr algn="l">
-              <a:spcBef>
-                <a:spcPts val="0"/>
-              </a:spcBef>
-              <a:spcAft>
-                <a:spcPts val="200"/>
-              </a:spcAft>
-            </a:pPr>
-            <a:r>
-              <a:rPr sz="900" b="0">
-                <a:solidFill>
-                  <a:srgbClr val="64748B"/>
-                </a:solidFill>
-              </a:rPr>
-              <a:t>rank top dock locations</a:t>
+                  <a:srgbClr val="94A3B8"/>
+                </a:solidFill>
+              </a:rPr>
+              <a:t>MTA scores rank locations</a:t>
             </a:r>
           </a:p>
         </p:txBody>
@@ -2917,7 +2863,7 @@
             <a:r>
               <a:rPr sz="1100" b="1">
                 <a:solidFill>
-                  <a:srgbClr val="2D7FF9"/>
+                  <a:srgbClr val="FF00BF"/>
                 </a:solidFill>
               </a:rPr>
               <a:t>Transit Opportunity Score</a:t>
@@ -2962,14 +2908,32 @@
               <a:buNone/>
             </a:pPr>
             <a:r>
+              <a:rPr sz="1000" b="0">
+                <a:solidFill>
+                  <a:srgbClr val="FFFFFF"/>
+                </a:solidFill>
+              </a:rPr>
+              <a:t>Score 0–100 combining:</a:t>
+            </a:r>
+            <a:endParaRPr lang="en-US" sz="1300" dirty="0"/>
+          </a:p>
+          <a:p>
+            <a:pPr algn="l">
+              <a:spcBef>
+                <a:spcPts val="0"/>
+              </a:spcBef>
+              <a:spcAft>
+                <a:spcPts val="200"/>
+              </a:spcAft>
+            </a:pPr>
+            <a:r>
               <a:rPr sz="900" b="0">
                 <a:solidFill>
-                  <a:srgbClr val="0F172A"/>
-                </a:solidFill>
-              </a:rPr>
-              <a:t>Score 0–100 combining:</a:t>
-            </a:r>
-            <a:endParaRPr lang="en-US" sz="1300" dirty="0"/>
+                  <a:srgbClr val="94A3B8"/>
+                </a:solidFill>
+              </a:rPr>
+              <a:t>MTA ridership + delay rates</a:t>
+            </a:r>
           </a:p>
           <a:p>
             <a:pPr algn="l">
@@ -2977,16 +2941,16 @@
                 <a:spcPts val="0"/>
               </a:spcBef>
               <a:spcAft>
-                <a:spcPts val="200"/>
+                <a:spcPts val="400"/>
               </a:spcAft>
             </a:pPr>
             <a:r>
               <a:rPr sz="900" b="0">
                 <a:solidFill>
-                  <a:srgbClr val="64748B"/>
-                </a:solidFill>
-              </a:rPr>
-              <a:t>MTA ridership + delay rates</a:t>
+                  <a:srgbClr val="94A3B8"/>
+                </a:solidFill>
+              </a:rPr>
+              <a:t>+ bike station proximity</a:t>
             </a:r>
           </a:p>
           <a:p>
@@ -2999,48 +2963,12 @@
               </a:spcAft>
             </a:pPr>
             <a:r>
-              <a:rPr sz="900" b="0">
-                <a:solidFill>
-                  <a:srgbClr val="64748B"/>
-                </a:solidFill>
-              </a:rPr>
-              <a:t>+ bike station proximity</a:t>
-            </a:r>
-          </a:p>
-          <a:p>
-            <a:pPr algn="l">
-              <a:spcBef>
-                <a:spcPts val="0"/>
-              </a:spcBef>
-              <a:spcAft>
-                <a:spcPts val="200"/>
-              </a:spcAft>
-            </a:pPr>
-            <a:r>
-              <a:rPr sz="400" b="0">
-                <a:solidFill>
-                  <a:srgbClr val="0F172A"/>
-                </a:solidFill>
-              </a:rPr>
-              <a:t/>
-            </a:r>
-          </a:p>
-          <a:p>
-            <a:pPr algn="l">
-              <a:spcBef>
-                <a:spcPts val="0"/>
-              </a:spcBef>
-              <a:spcAft>
-                <a:spcPts val="200"/>
-              </a:spcAft>
-            </a:pPr>
-            <a:r>
-              <a:rPr sz="900" b="1">
-                <a:solidFill>
-                  <a:srgbClr val="0F172A"/>
-                </a:solidFill>
-              </a:rPr>
-              <a:t>High score = unmet demand</a:t>
+              <a:rPr sz="1000" b="1">
+                <a:solidFill>
+                  <a:srgbClr val="FF00BF"/>
+                </a:solidFill>
+              </a:rPr>
+              <a:t>High = unmet transit demand</a:t>
             </a:r>
           </a:p>
         </p:txBody>
@@ -3209,25 +3137,28 @@
           <a:ln/>
         </p:spPr>
         <p:txBody>
-          <a:bodyPr wrap="none" lIns="0" tIns="0" rIns="0" bIns="0" rtlCol="0" anchor="t"/>
+          <a:bodyPr wrap="square" lIns="0" tIns="0" rIns="0" bIns="0" rtlCol="0" anchor="t"/>
           <a:lstStyle/>
           <a:p>
             <a:pPr marL="0" indent="0" algn="l">
               <a:lnSpc>
                 <a:spcPct val="104000"/>
               </a:lnSpc>
+              <a:spcBef>
+                <a:spcPts val="0"/>
+              </a:spcBef>
+              <a:spcAft>
+                <a:spcPts val="200"/>
+              </a:spcAft>
               <a:buNone/>
             </a:pPr>
             <a:r>
-              <a:rPr lang="en-US" sz="3250" b="1" dirty="0">
-                <a:solidFill>
-                  <a:srgbClr val="05336B"/>
-                </a:solidFill>
-                <a:latin typeface="Nunito Sans Bold" pitchFamily="34" charset="0"/>
-                <a:ea typeface="Nunito Sans Bold" pitchFamily="34" charset="-122"/>
-                <a:cs typeface="Nunito Sans Bold" pitchFamily="34" charset="-120"/>
-              </a:rPr>
-              <a:t>Model Demo</a:t>
+              <a:rPr sz="1800" b="1">
+                <a:solidFill>
+                  <a:srgbClr val="FFFFFF"/>
+                </a:solidFill>
+              </a:rPr>
+              <a:t>Live Dashboard Demo</a:t>
             </a:r>
             <a:endParaRPr lang="en-US" sz="3250" dirty="0"/>
           </a:p>
@@ -3256,7 +3187,7 @@
           </a:bodyPr>
           <a:lstStyle/>
           <a:p>
-            <a:pPr algn="l">
+            <a:pPr algn="ctr">
               <a:lnSpc>
                 <a:spcPct val="133000"/>
               </a:lnSpc>
@@ -3268,107 +3199,41 @@
               </a:spcAft>
             </a:pPr>
             <a:r>
-              <a:rPr sz="1400" b="1">
-                <a:solidFill>
-                  <a:srgbClr val="0F172A"/>
-                </a:solidFill>
-              </a:rPr>
-              <a:t>Live demo:</a:t>
+              <a:rPr sz="1800" b="1">
+                <a:solidFill>
+                  <a:srgbClr val="FF00BF"/>
+                </a:solidFill>
+              </a:rPr>
+              <a:t>citibike-citycycle.streamlit.app</a:t>
             </a:r>
             <a:endParaRPr lang="en-US" sz="1300" dirty="0"/>
           </a:p>
-          <a:p>
-            <a:pPr algn="l">
-              <a:spcBef>
-                <a:spcPts val="0"/>
-              </a:spcBef>
-              <a:spcAft>
-                <a:spcPts val="1000"/>
-              </a:spcAft>
-            </a:pPr>
-            <a:r>
-              <a:rPr sz="1400" b="1">
-                <a:solidFill>
-                  <a:srgbClr val="FF00BF"/>
-                </a:solidFill>
-              </a:rPr>
-              <a:t>citibike-citycycle.streamlit.app</a:t>
-            </a:r>
-          </a:p>
-          <a:p>
-            <a:pPr algn="l">
-              <a:spcBef>
-                <a:spcPts val="0"/>
-              </a:spcBef>
-              <a:spcAft>
-                <a:spcPts val="200"/>
-              </a:spcAft>
-            </a:pPr>
-            <a:r>
-              <a:rPr sz="1100" b="0">
-                <a:solidFill>
-                  <a:srgbClr val="0F172A"/>
-                </a:solidFill>
-              </a:rPr>
-              <a:t>▸ Forecast Lab — weather &amp; policy scenarios</a:t>
-            </a:r>
-          </a:p>
-          <a:p>
-            <a:pPr algn="l">
-              <a:spcBef>
-                <a:spcPts val="0"/>
-              </a:spcBef>
-              <a:spcAft>
-                <a:spcPts val="200"/>
-              </a:spcAft>
-            </a:pPr>
-            <a:r>
-              <a:rPr sz="1100" b="0">
-                <a:solidFill>
-                  <a:srgbClr val="0F172A"/>
-                </a:solidFill>
-              </a:rPr>
-              <a:t>▸ Gov Investment — budget, NPV, IRR, cash flow</a:t>
-            </a:r>
-          </a:p>
-          <a:p>
-            <a:pPr algn="l">
-              <a:spcBef>
-                <a:spcPts val="0"/>
-              </a:spcBef>
-              <a:spcAft>
-                <a:spcPts val="200"/>
-              </a:spcAft>
-            </a:pPr>
-            <a:r>
-              <a:rPr sz="1100" b="0">
-                <a:solidFill>
-                  <a:srgbClr val="0F172A"/>
-                </a:solidFill>
-              </a:rPr>
-              <a:t>▸ Station Explorer — click any station</a:t>
-            </a:r>
-          </a:p>
-          <a:p>
-            <a:pPr algn="l">
-              <a:spcBef>
-                <a:spcPts val="0"/>
-              </a:spcBef>
-              <a:spcAft>
-                <a:spcPts val="200"/>
-              </a:spcAft>
-            </a:pPr>
-            <a:r>
-              <a:rPr sz="1100" b="0">
-                <a:solidFill>
-                  <a:srgbClr val="0F172A"/>
-                </a:solidFill>
-              </a:rPr>
-              <a:t>▸ MTA Connection — transit vs bike demand</a:t>
-            </a:r>
-          </a:p>
-        </p:txBody>
-      </p:sp>
+        </p:txBody>
+      </p:sp>
+      <p:pic>
+        <p:nvPicPr>
+          <p:cNvPr id="6" name="Picture 5" descr="forecast.png"/>
+          <p:cNvPicPr>
+            <a:picLocks noChangeAspect="1"/>
+          </p:cNvPicPr>
+          <p:nvPr/>
+        </p:nvPicPr>
+        <p:blipFill>
+          <a:blip r:embed="rId3"/>
+          <a:stretch>
+            <a:fillRect/>
+          </a:stretch>
+        </p:blipFill>
+        <p:spPr>
+          <a:xfrm>
+            <a:off x="640080" y="2560320"/>
+            <a:ext cx="10515600" cy="3657600"/>
+          </a:xfrm>
+          <a:prstGeom prst="rect">
+            <a:avLst/>
+          </a:prstGeom>
+        </p:spPr>
+      </p:pic>
     </p:spTree>
   </p:cSld>
   <p:clrMapOvr>
@@ -3492,10 +3357,10 @@
             <a:r>
               <a:rPr sz="1200" b="0">
                 <a:solidFill>
-                  <a:srgbClr val="64748B"/>
-                </a:solidFill>
-              </a:rPr>
-              <a:t>The numbers that matter:</a:t>
+                  <a:srgbClr val="94A3B8"/>
+                </a:solidFill>
+              </a:rPr>
+              <a:t>Where to expand: Top 10 transit opportunity zones</a:t>
             </a:r>
             <a:endParaRPr lang="en-US" sz="1300" dirty="0"/>
           </a:p>
@@ -3541,138 +3406,12 @@
               </a:spcAft>
             </a:pPr>
             <a:r>
-              <a:rPr sz="2200" b="1">
-                <a:solidFill>
-                  <a:srgbClr val="FF00BF"/>
-                </a:solidFill>
-              </a:rPr>
-              <a:t>$196 M / yr</a:t>
-            </a:r>
-          </a:p>
-          <a:p>
-            <a:pPr algn="l">
-              <a:spcBef>
-                <a:spcPts val="0"/>
-              </a:spcBef>
-              <a:spcAft>
-                <a:spcPts val="800"/>
-              </a:spcAft>
-            </a:pPr>
-            <a:r>
-              <a:rPr sz="1000" b="0">
-                <a:solidFill>
-                  <a:srgbClr val="64748B"/>
-                </a:solidFill>
-              </a:rPr>
-              <a:t>Citi Bike annual revenue</a:t>
-            </a:r>
-          </a:p>
-          <a:p>
-            <a:pPr algn="l">
-              <a:spcBef>
-                <a:spcPts val="0"/>
-              </a:spcBef>
-              <a:spcAft>
-                <a:spcPts val="200"/>
-              </a:spcAft>
-            </a:pPr>
-            <a:r>
-              <a:rPr sz="2200" b="1">
-                <a:solidFill>
-                  <a:srgbClr val="2D7FF9"/>
-                </a:solidFill>
-              </a:rPr>
-              <a:t>11.24 MAE</a:t>
-            </a:r>
-          </a:p>
-          <a:p>
-            <a:pPr algn="l">
-              <a:spcBef>
-                <a:spcPts val="0"/>
-              </a:spcBef>
-              <a:spcAft>
-                <a:spcPts val="800"/>
-              </a:spcAft>
-            </a:pPr>
-            <a:r>
-              <a:rPr sz="1000" b="0">
-                <a:solidFill>
-                  <a:srgbClr val="64748B"/>
-                </a:solidFill>
-              </a:rPr>
-              <a:t>42.5 % better than baseline</a:t>
-            </a:r>
-          </a:p>
-          <a:p>
-            <a:pPr algn="l">
-              <a:spcBef>
-                <a:spcPts val="0"/>
-              </a:spcBef>
-              <a:spcAft>
-                <a:spcPts val="200"/>
-              </a:spcAft>
-            </a:pPr>
-            <a:r>
-              <a:rPr sz="2200" b="1">
-                <a:solidFill>
-                  <a:srgbClr val="10B981"/>
-                </a:solidFill>
-              </a:rPr>
-              <a:t>17-month payback</a:t>
-            </a:r>
-          </a:p>
-          <a:p>
-            <a:pPr algn="l">
-              <a:spcBef>
-                <a:spcPts val="0"/>
-              </a:spcBef>
-              <a:spcAft>
-                <a:spcPts val="800"/>
-              </a:spcAft>
-            </a:pPr>
-            <a:r>
-              <a:rPr sz="1000" b="0">
-                <a:solidFill>
-                  <a:srgbClr val="64748B"/>
-                </a:solidFill>
-              </a:rPr>
-              <a:t>250 new stations pay for themselves</a:t>
-            </a:r>
-          </a:p>
-          <a:p>
-            <a:pPr algn="l">
-              <a:spcBef>
-                <a:spcPts val="0"/>
-              </a:spcBef>
-              <a:spcAft>
-                <a:spcPts val="200"/>
-              </a:spcAft>
-            </a:pPr>
-            <a:r>
-              <a:rPr sz="2200" b="1">
+              <a:rPr sz="100" b="0">
                 <a:solidFill>
                   <a:srgbClr val="0F172A"/>
                 </a:solidFill>
               </a:rPr>
-              <a:t>0.987 correlation</a:t>
-            </a:r>
-          </a:p>
-          <a:p>
-            <a:pPr algn="l">
-              <a:spcBef>
-                <a:spcPts val="0"/>
-              </a:spcBef>
-              <a:spcAft>
-                <a:spcPts val="200"/>
-              </a:spcAft>
-            </a:pPr>
-            <a:r>
-              <a:rPr sz="1000" b="0">
-                <a:solidFill>
-                  <a:srgbClr val="64748B"/>
-                </a:solidFill>
-              </a:rPr>
-              <a:t>actual vs predicted daily demand</a:t>
+              <a:t/>
             </a:r>
           </a:p>
         </p:txBody>
@@ -3703,6 +3442,30 @@
           <a:xfrm>
             <a:off x="11341993" y="6007993"/>
             <a:ext cx="850007" cy="850007"/>
+          </a:xfrm>
+          <a:prstGeom prst="rect">
+            <a:avLst/>
+          </a:prstGeom>
+        </p:spPr>
+      </p:pic>
+      <p:pic>
+        <p:nvPicPr>
+          <p:cNvPr id="16" name="Picture 15" descr="top10.png"/>
+          <p:cNvPicPr>
+            <a:picLocks noChangeAspect="1"/>
+          </p:cNvPicPr>
+          <p:nvPr/>
+        </p:nvPicPr>
+        <p:blipFill>
+          <a:blip r:embed="rId4"/>
+          <a:stretch>
+            <a:fillRect/>
+          </a:stretch>
+        </p:blipFill>
+        <p:spPr>
+          <a:xfrm>
+            <a:off x="457200" y="2011680"/>
+            <a:ext cx="10789920" cy="3840480"/>
           </a:xfrm>
           <a:prstGeom prst="rect">
             <a:avLst/>
@@ -3819,10 +3582,10 @@
             <a:r>
               <a:rPr sz="1200" b="0">
                 <a:solidFill>
-                  <a:srgbClr val="64748B"/>
-                </a:solidFill>
-              </a:rPr>
-              <a:t>From data to dollars:</a:t>
+                  <a:srgbClr val="94A3B8"/>
+                </a:solidFill>
+              </a:rPr>
+              <a:t>The investment case in three numbers:</a:t>
             </a:r>
             <a:endParaRPr lang="en-US" sz="1300" dirty="0"/>
           </a:p>
@@ -3892,14 +3655,50 @@
               </a:spcAft>
             </a:pPr>
             <a:r>
+              <a:rPr sz="2400" b="1">
+                <a:solidFill>
+                  <a:srgbClr val="FF00BF"/>
+                </a:solidFill>
+              </a:rPr>
+              <a:t>$11.3M/yr</a:t>
+            </a:r>
+            <a:endParaRPr lang="en-US" sz="1300" dirty="0"/>
+          </a:p>
+          <a:p>
+            <a:pPr algn="l">
+              <a:spcBef>
+                <a:spcPts val="0"/>
+              </a:spcBef>
+              <a:spcAft>
+                <a:spcPts val="800"/>
+              </a:spcAft>
+            </a:pPr>
+            <a:r>
+              <a:rPr sz="1100" b="0">
+                <a:solidFill>
+                  <a:srgbClr val="FFFFFF"/>
+                </a:solidFill>
+              </a:rPr>
+              <a:t>net operating profit from 250 new stations</a:t>
+            </a:r>
+          </a:p>
+          <a:p>
+            <a:pPr algn="l">
+              <a:spcBef>
+                <a:spcPts val="0"/>
+              </a:spcBef>
+              <a:spcAft>
+                <a:spcPts val="200"/>
+              </a:spcAft>
+            </a:pPr>
+            <a:r>
               <a:rPr sz="1800" b="1">
                 <a:solidFill>
-                  <a:srgbClr val="FF00BF"/>
-                </a:solidFill>
-              </a:rPr>
-              <a:t>$11.3 M / yr  net profit</a:t>
-            </a:r>
-            <a:endParaRPr lang="en-US" sz="1300" dirty="0"/>
+                  <a:srgbClr val="FFFFFF"/>
+                </a:solidFill>
+              </a:rPr>
+              <a:t>$32M total investment</a:t>
+            </a:r>
           </a:p>
           <a:p>
             <a:pPr algn="l">
@@ -3907,70 +3706,34 @@
                 <a:spcPts val="0"/>
               </a:spcBef>
               <a:spcAft>
-                <a:spcPts val="600"/>
+                <a:spcPts val="800"/>
+              </a:spcAft>
+            </a:pPr>
+            <a:r>
+              <a:rPr sz="1800" b="1">
+                <a:solidFill>
+                  <a:srgbClr val="10B981"/>
+                </a:solidFill>
+              </a:rPr>
+              <a:t>17-month payback</a:t>
+            </a:r>
+          </a:p>
+          <a:p>
+            <a:pPr algn="l">
+              <a:spcBef>
+                <a:spcPts val="0"/>
+              </a:spcBef>
+              <a:spcAft>
+                <a:spcPts val="200"/>
               </a:spcAft>
             </a:pPr>
             <a:r>
               <a:rPr sz="1000" b="0">
                 <a:solidFill>
-                  <a:srgbClr val="64748B"/>
-                </a:solidFill>
-              </a:rPr>
-              <a:t>from 250 new stations</a:t>
-            </a:r>
-          </a:p>
-          <a:p>
-            <a:pPr algn="l">
-              <a:spcBef>
-                <a:spcPts val="0"/>
-              </a:spcBef>
-              <a:spcAft>
-                <a:spcPts val="200"/>
-              </a:spcAft>
-            </a:pPr>
-            <a:r>
-              <a:rPr sz="1400" b="1">
-                <a:solidFill>
-                  <a:srgbClr val="0F172A"/>
-                </a:solidFill>
-              </a:rPr>
-              <a:t>$32 M investment  ·  17-month payback</a:t>
-            </a:r>
-          </a:p>
-          <a:p>
-            <a:pPr algn="l">
-              <a:spcBef>
-                <a:spcPts val="0"/>
-              </a:spcBef>
-              <a:spcAft>
-                <a:spcPts val="200"/>
-              </a:spcAft>
-            </a:pPr>
-            <a:r>
-              <a:rPr sz="400" b="0">
-                <a:solidFill>
-                  <a:srgbClr val="0F172A"/>
-                </a:solidFill>
-              </a:rPr>
-              <a:t/>
-            </a:r>
-          </a:p>
-          <a:p>
-            <a:pPr algn="l">
-              <a:spcBef>
-                <a:spcPts val="0"/>
-              </a:spcBef>
-              <a:spcAft>
-                <a:spcPts val="200"/>
-              </a:spcAft>
-            </a:pPr>
-            <a:r>
-              <a:rPr sz="1000" b="0">
-                <a:solidFill>
                   <a:srgbClr val="2D7FF9"/>
                 </a:solidFill>
               </a:rPr>
-              <a:t>Public benefit: reduced congestion, lower emissions, better transit for 8.3 M residents</a:t>
+              <a:t>Reduced congestion + lower emissions for 8.3M residents</a:t>
             </a:r>
           </a:p>
         </p:txBody>
@@ -4185,7 +3948,7 @@
             <a:r>
               <a:rPr sz="1200" b="1">
                 <a:solidFill>
-                  <a:srgbClr val="0F172A"/>
+                  <a:srgbClr val="FFFFFF"/>
                 </a:solidFill>
               </a:rPr>
               <a:t>Strategic Next Steps</a:t>
@@ -4351,10 +4114,10 @@
             <a:r>
               <a:rPr sz="900" b="0">
                 <a:solidFill>
-                  <a:srgbClr val="0F172A"/>
-                </a:solidFill>
-              </a:rPr>
-              <a:t>Deploy 50 stations in top MTA zones.</a:t>
+                  <a:srgbClr val="FFFFFF"/>
+                </a:solidFill>
+              </a:rPr>
+              <a:t>50 stations in top MTA zones</a:t>
             </a:r>
             <a:endParaRPr lang="en-US" sz="1100" dirty="0"/>
           </a:p>
@@ -4370,10 +4133,10 @@
             <a:r>
               <a:rPr sz="900" b="0">
                 <a:solidFill>
-                  <a:srgbClr val="64748B"/>
-                </a:solidFill>
-              </a:rPr>
-              <a:t>Measure actual vs predicted over 6 mo.</a:t>
+                  <a:srgbClr val="94A3B8"/>
+                </a:solidFill>
+              </a:rPr>
+              <a:t>Measure actual vs predicted × 6 months</a:t>
             </a:r>
           </a:p>
         </p:txBody>
@@ -4482,10 +4245,10 @@
             <a:r>
               <a:rPr sz="900" b="0">
                 <a:solidFill>
-                  <a:srgbClr val="0F172A"/>
-                </a:solidFill>
-              </a:rPr>
-              <a:t>Roll out 200 remaining stations.</a:t>
+                  <a:srgbClr val="FFFFFF"/>
+                </a:solidFill>
+              </a:rPr>
+              <a:t>200 remaining stations</a:t>
             </a:r>
             <a:endParaRPr lang="en-US" sz="1100" dirty="0"/>
           </a:p>
@@ -4501,10 +4264,10 @@
             <a:r>
               <a:rPr sz="900" b="0">
                 <a:solidFill>
-                  <a:srgbClr val="64748B"/>
-                </a:solidFill>
-              </a:rPr>
-              <a:t>Integrate real-time MTA delay feeds.</a:t>
+                  <a:srgbClr val="94A3B8"/>
+                </a:solidFill>
+              </a:rPr>
+              <a:t>Integrate real-time MTA delay feeds</a:t>
             </a:r>
           </a:p>
         </p:txBody>
@@ -4569,7 +4332,7 @@
             <a:r>
               <a:rPr sz="1100" b="1">
                 <a:solidFill>
-                  <a:srgbClr val="2D7FF9"/>
+                  <a:srgbClr val="FF00BF"/>
                 </a:solidFill>
               </a:rPr>
               <a:t>Phase 3: Optimize</a:t>
@@ -4853,7 +4616,7 @@
             <a:r>
               <a:rPr sz="1200" b="1">
                 <a:solidFill>
-                  <a:srgbClr val="2D7FF9"/>
+                  <a:srgbClr val="FF00BF"/>
                 </a:solidFill>
               </a:rPr>
               <a:t>The Problem</a:t>
@@ -4898,31 +4661,31 @@
               <a:buNone/>
             </a:pPr>
             <a:r>
+              <a:rPr sz="1100" b="1">
+                <a:solidFill>
+                  <a:srgbClr val="FFFFFF"/>
+                </a:solidFill>
+              </a:rPr>
+              <a:t>50% of stations maxed out.</a:t>
+            </a:r>
+            <a:endParaRPr lang="en-US" sz="1150" dirty="0"/>
+          </a:p>
+          <a:p>
+            <a:pPr algn="l">
+              <a:spcBef>
+                <a:spcPts val="0"/>
+              </a:spcBef>
+              <a:spcAft>
+                <a:spcPts val="200"/>
+              </a:spcAft>
+            </a:pPr>
+            <a:r>
               <a:rPr sz="1000" b="0">
                 <a:solidFill>
-                  <a:srgbClr val="0F172A"/>
-                </a:solidFill>
-              </a:rPr>
-              <a:t>50 % of stations are maxed out while MTA service deteriorates.</a:t>
-            </a:r>
-            <a:endParaRPr lang="en-US" sz="1150" dirty="0"/>
-          </a:p>
-          <a:p>
-            <a:pPr algn="l">
-              <a:spcBef>
-                <a:spcPts val="0"/>
-              </a:spcBef>
-              <a:spcAft>
-                <a:spcPts val="200"/>
-              </a:spcAft>
-            </a:pPr>
-            <a:r>
-              <a:rPr sz="1000" b="0">
-                <a:solidFill>
-                  <a:srgbClr val="64748B"/>
-                </a:solidFill>
-              </a:rPr>
-              <a:t>8.3 M residents need better options.</a:t>
+                  <a:srgbClr val="94A3B8"/>
+                </a:solidFill>
+              </a:rPr>
+              <a:t>MTA deteriorating. 8.3M residents need options.</a:t>
             </a:r>
           </a:p>
         </p:txBody>
@@ -5056,10 +4819,10 @@
             <a:r>
               <a:rPr sz="1200" b="1">
                 <a:solidFill>
-                  <a:srgbClr val="2D7FF9"/>
-                </a:solidFill>
-              </a:rPr>
-              <a:t>The Core Insight</a:t>
+                  <a:srgbClr val="FF00BF"/>
+                </a:solidFill>
+              </a:rPr>
+              <a:t>The Insight</a:t>
             </a:r>
             <a:endParaRPr lang="en-US" sz="1450" dirty="0"/>
           </a:p>
@@ -5101,9 +4864,9 @@
               <a:buNone/>
             </a:pPr>
             <a:r>
-              <a:rPr sz="1000" b="1">
-                <a:solidFill>
-                  <a:srgbClr val="0F172A"/>
+              <a:rPr sz="1100" b="1">
+                <a:solidFill>
+                  <a:srgbClr val="FFFFFF"/>
                 </a:solidFill>
               </a:rPr>
               <a:t>Demand is predictable.</a:t>
@@ -5122,10 +4885,10 @@
             <a:r>
               <a:rPr sz="1000" b="0">
                 <a:solidFill>
-                  <a:srgbClr val="64748B"/>
-                </a:solidFill>
-              </a:rPr>
-              <a:t>XGBoost forecasts with 11.24 MAE. MTA data shows exactly where to expand.</a:t>
+                  <a:srgbClr val="94A3B8"/>
+                </a:solidFill>
+              </a:rPr>
+              <a:t>XGBoost MAE 11.24. MTA data shows exactly where to expand.</a:t>
             </a:r>
           </a:p>
         </p:txBody>
@@ -5259,7 +5022,7 @@
             <a:r>
               <a:rPr sz="1200" b="1">
                 <a:solidFill>
-                  <a:srgbClr val="2D7FF9"/>
+                  <a:srgbClr val="FF00BF"/>
                 </a:solidFill>
               </a:rPr>
               <a:t>The Value</a:t>
@@ -5304,12 +5067,12 @@
               <a:buNone/>
             </a:pPr>
             <a:r>
-              <a:rPr sz="1200" b="1">
+              <a:rPr sz="1300" b="1">
                 <a:solidFill>
                   <a:srgbClr val="FF00BF"/>
                 </a:solidFill>
               </a:rPr>
-              <a:t>250 stations → $11.3 M/yr</a:t>
+              <a:t>250 stations → $11.3M/yr</a:t>
             </a:r>
             <a:endParaRPr lang="en-US" sz="1150" dirty="0"/>
           </a:p>
@@ -5325,10 +5088,10 @@
             <a:r>
               <a:rPr sz="1000" b="0">
                 <a:solidFill>
-                  <a:srgbClr val="0F172A"/>
-                </a:solidFill>
-              </a:rPr>
-              <a:t>17-month payback. SF, DC, and Chicago prove the model.</a:t>
+                  <a:srgbClr val="FFFFFF"/>
+                </a:solidFill>
+              </a:rPr>
+              <a:t>17-month payback. The data says invest now.</a:t>
             </a:r>
           </a:p>
         </p:txBody>
@@ -5430,14 +5193,32 @@
               <a:buNone/>
             </a:pPr>
             <a:r>
-              <a:rPr sz="3200" b="1">
+              <a:rPr sz="3600" b="1">
+                <a:solidFill>
+                  <a:srgbClr val="FFFFFF"/>
+                </a:solidFill>
+              </a:rPr>
+              <a:t>Thank You</a:t>
+            </a:r>
+            <a:endParaRPr lang="en-US" sz="2900" dirty="0"/>
+          </a:p>
+          <a:p>
+            <a:pPr algn="ctr">
+              <a:spcBef>
+                <a:spcPts val="0"/>
+              </a:spcBef>
+              <a:spcAft>
+                <a:spcPts val="200"/>
+              </a:spcAft>
+            </a:pPr>
+            <a:r>
+              <a:rPr sz="1200" b="0">
                 <a:solidFill>
                   <a:srgbClr val="0F172A"/>
                 </a:solidFill>
               </a:rPr>
-              <a:t>Thank You</a:t>
-            </a:r>
-            <a:endParaRPr lang="en-US" sz="2900" dirty="0"/>
+              <a:t/>
+            </a:r>
           </a:p>
           <a:p>
             <a:pPr algn="ctr">
@@ -5449,7 +5230,25 @@
               </a:spcAft>
             </a:pPr>
             <a:r>
-              <a:rPr sz="1000" b="0">
+              <a:rPr sz="1800" b="0">
+                <a:solidFill>
+                  <a:srgbClr val="2D7FF9"/>
+                </a:solidFill>
+              </a:rPr>
+              <a:t>Nathan  ·  Jenny  ·  Nosaifa</a:t>
+            </a:r>
+          </a:p>
+          <a:p>
+            <a:pPr algn="ctr">
+              <a:spcBef>
+                <a:spcPts val="0"/>
+              </a:spcBef>
+              <a:spcAft>
+                <a:spcPts val="200"/>
+              </a:spcAft>
+            </a:pPr>
+            <a:r>
+              <a:rPr sz="800" b="0">
                 <a:solidFill>
                   <a:srgbClr val="0F172A"/>
                 </a:solidFill>
@@ -5467,12 +5266,12 @@
               </a:spcAft>
             </a:pPr>
             <a:r>
-              <a:rPr sz="1600" b="0">
-                <a:solidFill>
-                  <a:srgbClr val="2D7FF9"/>
-                </a:solidFill>
-              </a:rPr>
-              <a:t>Nathan  ·  Jenny  ·  Nosaifa</a:t>
+              <a:rPr sz="1400" b="0">
+                <a:solidFill>
+                  <a:srgbClr val="FF00BF"/>
+                </a:solidFill>
+              </a:rPr>
+              <a:t>citibike-citycycle.streamlit.app</a:t>
             </a:r>
           </a:p>
           <a:p>
@@ -5485,7 +5284,7 @@
               </a:spcAft>
             </a:pPr>
             <a:r>
-              <a:rPr sz="800" b="0">
+              <a:rPr sz="1200" b="0">
                 <a:solidFill>
                   <a:srgbClr val="0F172A"/>
                 </a:solidFill>
@@ -5503,45 +5302,9 @@
               </a:spcAft>
             </a:pPr>
             <a:r>
-              <a:rPr sz="1400" b="0">
-                <a:solidFill>
-                  <a:srgbClr val="FF00BF"/>
-                </a:solidFill>
-              </a:rPr>
-              <a:t>citibike-citycycle.streamlit.app</a:t>
-            </a:r>
-          </a:p>
-          <a:p>
-            <a:pPr algn="ctr">
-              <a:spcBef>
-                <a:spcPts val="0"/>
-              </a:spcBef>
-              <a:spcAft>
-                <a:spcPts val="200"/>
-              </a:spcAft>
-            </a:pPr>
-            <a:r>
-              <a:rPr sz="1000" b="0">
-                <a:solidFill>
-                  <a:srgbClr val="0F172A"/>
-                </a:solidFill>
-              </a:rPr>
-              <a:t/>
-            </a:r>
-          </a:p>
-          <a:p>
-            <a:pPr algn="ctr">
-              <a:spcBef>
-                <a:spcPts val="0"/>
-              </a:spcBef>
-              <a:spcAft>
-                <a:spcPts val="200"/>
-              </a:spcAft>
-            </a:pPr>
-            <a:r>
-              <a:rPr sz="1600" b="0">
-                <a:solidFill>
-                  <a:srgbClr val="64748B"/>
+              <a:rPr sz="1800" b="0">
+                <a:solidFill>
+                  <a:srgbClr val="94A3B8"/>
                 </a:solidFill>
               </a:rPr>
               <a:t>Questions?</a:t>
@@ -5739,10 +5502,10 @@
             <a:r>
               <a:rPr sz="1100" b="1">
                 <a:solidFill>
-                  <a:srgbClr val="0F172A"/>
-                </a:solidFill>
-              </a:rPr>
-              <a:t>Nathan  —  Data Engineer &amp; Backend Lead</a:t>
+                  <a:srgbClr val="FFFFFF"/>
+                </a:solidFill>
+              </a:rPr>
+              <a:t>Nathan — Data Engineer &amp; Backend</a:t>
             </a:r>
             <a:endParaRPr lang="en-US" sz="1600" dirty="0"/>
           </a:p>
@@ -5812,12 +5575,12 @@
               <a:buNone/>
             </a:pPr>
             <a:r>
-              <a:rPr sz="1000" b="0">
-                <a:solidFill>
-                  <a:srgbClr val="64748B"/>
-                </a:solidFill>
-              </a:rPr>
-              <a:t>Data pipeline · ETL · Revenue modeling · MTA integration</a:t>
+              <a:rPr sz="900" b="0">
+                <a:solidFill>
+                  <a:srgbClr val="94A3B8"/>
+                </a:solidFill>
+              </a:rPr>
+              <a:t>Pipeline  ·  ETL  ·  Revenue modeling  ·  MTA integration</a:t>
             </a:r>
             <a:endParaRPr lang="en-US" sz="1600" dirty="0"/>
           </a:p>
@@ -5900,10 +5663,10 @@
             <a:r>
               <a:rPr sz="1100" b="1">
                 <a:solidFill>
-                  <a:srgbClr val="0F172A"/>
-                </a:solidFill>
-              </a:rPr>
-              <a:t>Jenny  —  Data Analyst &amp; Dashboard Lead</a:t>
+                  <a:srgbClr val="FFFFFF"/>
+                </a:solidFill>
+              </a:rPr>
+              <a:t>Jenny — Data Analyst &amp; Dashboard</a:t>
             </a:r>
             <a:endParaRPr lang="en-US" sz="1600" dirty="0"/>
           </a:p>
@@ -5985,12 +5748,12 @@
               <a:buNone/>
             </a:pPr>
             <a:r>
-              <a:rPr sz="1000" b="0">
-                <a:solidFill>
-                  <a:srgbClr val="64748B"/>
-                </a:solidFill>
-              </a:rPr>
-              <a:t>Streamlit dashboard · Plotly charts · UX design</a:t>
+              <a:rPr sz="900" b="0">
+                <a:solidFill>
+                  <a:srgbClr val="94A3B8"/>
+                </a:solidFill>
+              </a:rPr>
+              <a:t>Streamlit dashboard  ·  Plotly charts  ·  UX design</a:t>
             </a:r>
             <a:endParaRPr lang="en-US" sz="1600" dirty="0"/>
           </a:p>
@@ -6073,10 +5836,10 @@
             <a:r>
               <a:rPr sz="1100" b="1">
                 <a:solidFill>
-                  <a:srgbClr val="0F172A"/>
-                </a:solidFill>
-              </a:rPr>
-              <a:t>Nosaifa  —  ML Engineer &amp; Forecast Lead</a:t>
+                  <a:srgbClr val="FFFFFF"/>
+                </a:solidFill>
+              </a:rPr>
+              <a:t>Nosaifa — ML Engineer &amp; Forecast</a:t>
             </a:r>
             <a:endParaRPr lang="en-US" sz="1600" dirty="0"/>
           </a:p>
@@ -6158,12 +5921,12 @@
               <a:buNone/>
             </a:pPr>
             <a:r>
-              <a:rPr sz="1000" b="0">
-                <a:solidFill>
-                  <a:srgbClr val="64748B"/>
-                </a:solidFill>
-              </a:rPr>
-              <a:t>XGBoost forecast · Feature engineering · Model evaluation</a:t>
+              <a:rPr sz="900" b="0">
+                <a:solidFill>
+                  <a:srgbClr val="94A3B8"/>
+                </a:solidFill>
+              </a:rPr>
+              <a:t>XGBoost  ·  Feature engineering  ·  Cross-validation</a:t>
             </a:r>
             <a:endParaRPr lang="en-US" sz="1600" dirty="0"/>
           </a:p>
@@ -6380,7 +6143,7 @@
             <a:r>
               <a:rPr sz="1400" b="1">
                 <a:solidFill>
-                  <a:srgbClr val="2D7FF9"/>
+                  <a:srgbClr val="FF00BF"/>
                 </a:solidFill>
               </a:rPr>
               <a:t>The Problem</a:t>
@@ -6425,12 +6188,12 @@
               <a:buNone/>
             </a:pPr>
             <a:r>
-              <a:rPr sz="1100" b="1">
+              <a:rPr sz="1200" b="1">
                 <a:solidFill>
                   <a:srgbClr val="0F172A"/>
                 </a:solidFill>
               </a:rPr>
-              <a:t>NYC's Citi Bike generates $196 M/yr — but 50 % of stations are at capacity.</a:t>
+              <a:t>Citi Bike is a $196M/yr business — but 50% of stations are at capacity.</a:t>
             </a:r>
             <a:endParaRPr lang="en-US" sz="1300" dirty="0"/>
           </a:p>
@@ -6467,7 +6230,7 @@
                   <a:srgbClr val="64748B"/>
                 </a:solidFill>
               </a:rPr>
-              <a:t>MTA delays are pushing commuters toward alternatives, yet there is no data-driven expansion plan.</a:t>
+              <a:t>MTA subway delays push commuters toward alternatives. No data-driven expansion plan exists.</a:t>
             </a:r>
           </a:p>
         </p:txBody>
@@ -6514,7 +6277,7 @@
                   <a:srgbClr val="0F172A"/>
                 </a:solidFill>
               </a:rPr>
-              <a:t>▸ 8.3 M NYC residents on aging transit</a:t>
+              <a:t>▸  8.3M residents depend on aging transit</a:t>
             </a:r>
             <a:endParaRPr lang="en-US" sz="1300" dirty="0"/>
           </a:p>
@@ -6553,7 +6316,7 @@
                   <a:srgbClr val="0F172A"/>
                 </a:solidFill>
               </a:rPr>
-              <a:t>▸ Lyft (operator) leaving revenue on the table</a:t>
+              <a:t>▸  Lyft leaves revenue on the table</a:t>
             </a:r>
           </a:p>
           <a:p>
@@ -6571,7 +6334,7 @@
                   <a:srgbClr val="0F172A"/>
                 </a:solidFill>
               </a:rPr>
-              <a:t>▸ City planners deciding without forecasts</a:t>
+              <a:t>▸  City planners lack demand forecasts</a:t>
             </a:r>
           </a:p>
           <a:p>
@@ -6589,7 +6352,7 @@
                   <a:srgbClr val="FF00BF"/>
                 </a:solidFill>
               </a:rPr>
-              <a:t>▸ ~$11.3 M/yr in unrealized net profit</a:t>
+              <a:t>▸  $11.3M/yr unrealized net profit</a:t>
             </a:r>
           </a:p>
         </p:txBody>
@@ -6630,7 +6393,7 @@
             <a:r>
               <a:rPr sz="1400" b="1">
                 <a:solidFill>
-                  <a:srgbClr val="2D7FF9"/>
+                  <a:srgbClr val="FFFFFF"/>
                 </a:solidFill>
               </a:rPr>
               <a:t>Global Context</a:t>
@@ -6711,12 +6474,30 @@
             <a:r>
               <a:rPr sz="1000" b="0">
                 <a:solidFill>
+                  <a:srgbClr val="FFFFFF"/>
+                </a:solidFill>
+              </a:rPr>
+              <a:t>China's dockless bike-share proved demand but failed globally (no docks, no gov partnership).</a:t>
+            </a:r>
+            <a:endParaRPr lang="en-US" sz="1300" dirty="0"/>
+          </a:p>
+          <a:p>
+            <a:pPr algn="l">
+              <a:spcBef>
+                <a:spcPts val="0"/>
+              </a:spcBef>
+              <a:spcAft>
+                <a:spcPts val="200"/>
+              </a:spcAft>
+            </a:pPr>
+            <a:r>
+              <a:rPr sz="400" b="0">
+                <a:solidFill>
                   <a:srgbClr val="0F172A"/>
                 </a:solidFill>
               </a:rPr>
-              <a:t>China's dockless bike-share proved global demand — but failed outside China (no docks, no gov partnership).</a:t>
-            </a:r>
-            <a:endParaRPr lang="en-US" sz="1300" dirty="0"/>
+              <a:t/>
+            </a:r>
           </a:p>
           <a:p>
             <a:pPr algn="l">
@@ -6728,30 +6509,12 @@
               </a:spcAft>
             </a:pPr>
             <a:r>
-              <a:rPr sz="400" b="0">
-                <a:solidFill>
-                  <a:srgbClr val="0F172A"/>
-                </a:solidFill>
-              </a:rPr>
-              <a:t/>
-            </a:r>
-          </a:p>
-          <a:p>
-            <a:pPr algn="l">
-              <a:spcBef>
-                <a:spcPts val="0"/>
-              </a:spcBef>
-              <a:spcAft>
-                <a:spcPts val="200"/>
-              </a:spcAft>
-            </a:pPr>
-            <a:r>
               <a:rPr sz="1000" b="1">
                 <a:solidFill>
-                  <a:srgbClr val="0F172A"/>
-                </a:solidFill>
-              </a:rPr>
-              <a:t>Citi Bike's dock-based model works. SF, DC, and Chicago confirm it.</a:t>
+                  <a:srgbClr val="FF00BF"/>
+                </a:solidFill>
+              </a:rPr>
+              <a:t>Citi Bike's dock-based model works. SF, DC, Chicago confirm it.</a:t>
             </a:r>
           </a:p>
         </p:txBody>
@@ -6974,10 +6737,10 @@
             <a:r>
               <a:rPr sz="1200" b="1">
                 <a:solidFill>
-                  <a:srgbClr val="2D7FF9"/>
-                </a:solidFill>
-              </a:rPr>
-              <a:t>Industry Impact</a:t>
+                  <a:srgbClr val="FF00BF"/>
+                </a:solidFill>
+              </a:rPr>
+              <a:t>Market Scale</a:t>
             </a:r>
             <a:endParaRPr lang="en-US" sz="1600" dirty="0"/>
           </a:p>
@@ -7019,12 +6782,12 @@
               <a:buNone/>
             </a:pPr>
             <a:r>
-              <a:rPr sz="1100" b="1">
-                <a:solidFill>
-                  <a:srgbClr val="0F172A"/>
-                </a:solidFill>
-              </a:rPr>
-              <a:t>$5 B+ global bike-share market</a:t>
+              <a:rPr sz="1600" b="1">
+                <a:solidFill>
+                  <a:srgbClr val="FFFFFF"/>
+                </a:solidFill>
+              </a:rPr>
+              <a:t>$5B+ global market</a:t>
             </a:r>
             <a:endParaRPr lang="en-US" sz="1300" dirty="0"/>
           </a:p>
@@ -7034,16 +6797,16 @@
                 <a:spcPts val="0"/>
               </a:spcBef>
               <a:spcAft>
-                <a:spcPts val="200"/>
+                <a:spcPts val="400"/>
               </a:spcAft>
             </a:pPr>
             <a:r>
               <a:rPr sz="1000" b="0">
                 <a:solidFill>
-                  <a:srgbClr val="64748B"/>
-                </a:solidFill>
-              </a:rPr>
-              <a:t>growing 12 % annually.</a:t>
+                  <a:srgbClr val="94A3B8"/>
+                </a:solidFill>
+              </a:rPr>
+              <a:t>growing 12% annually</a:t>
             </a:r>
           </a:p>
           <a:p>
@@ -7056,30 +6819,12 @@
               </a:spcAft>
             </a:pPr>
             <a:r>
-              <a:rPr sz="400" b="0">
-                <a:solidFill>
-                  <a:srgbClr val="0F172A"/>
-                </a:solidFill>
-              </a:rPr>
-              <a:t/>
-            </a:r>
-          </a:p>
-          <a:p>
-            <a:pPr algn="l">
-              <a:spcBef>
-                <a:spcPts val="0"/>
-              </a:spcBef>
-              <a:spcAft>
-                <a:spcPts val="200"/>
-              </a:spcAft>
-            </a:pPr>
-            <a:r>
               <a:rPr sz="1000" b="0">
                 <a:solidFill>
-                  <a:srgbClr val="64748B"/>
-                </a:solidFill>
-              </a:rPr>
-              <a:t>NYC operates the largest system in the Americas.</a:t>
+                  <a:srgbClr val="94A3B8"/>
+                </a:solidFill>
+              </a:rPr>
+              <a:t>NYC = largest system in Americas</a:t>
             </a:r>
           </a:p>
         </p:txBody>
@@ -7156,7 +6901,7 @@
             <a:r>
               <a:rPr sz="1200" b="1">
                 <a:solidFill>
-                  <a:srgbClr val="2D7FF9"/>
+                  <a:srgbClr val="FF00BF"/>
                 </a:solidFill>
               </a:rPr>
               <a:t>By the Numbers</a:t>
@@ -7201,12 +6946,12 @@
               <a:buNone/>
             </a:pPr>
             <a:r>
-              <a:rPr sz="1800" b="1">
+              <a:rPr sz="2000" b="1">
                 <a:solidFill>
                   <a:srgbClr val="FF00BF"/>
                 </a:solidFill>
               </a:rPr>
-              <a:t>$196 M / yr</a:t>
+              <a:t>$196M/yr</a:t>
             </a:r>
             <a:endParaRPr lang="en-US" sz="1300" dirty="0"/>
           </a:p>
@@ -7222,10 +6967,10 @@
             <a:r>
               <a:rPr sz="900" b="0">
                 <a:solidFill>
-                  <a:srgbClr val="64748B"/>
-                </a:solidFill>
-              </a:rPr>
-              <a:t>Citi Bike revenue</a:t>
+                  <a:srgbClr val="94A3B8"/>
+                </a:solidFill>
+              </a:rPr>
+              <a:t>annual revenue</a:t>
             </a:r>
           </a:p>
           <a:p>
@@ -7238,12 +6983,12 @@
               </a:spcAft>
             </a:pPr>
             <a:r>
-              <a:rPr sz="1800" b="1">
+              <a:rPr sz="2000" b="1">
                 <a:solidFill>
                   <a:srgbClr val="2D7FF9"/>
                 </a:solidFill>
               </a:rPr>
-              <a:t>60.9 M trips</a:t>
+              <a:t>60.9M trips</a:t>
             </a:r>
           </a:p>
           <a:p>
@@ -7258,7 +7003,7 @@
             <a:r>
               <a:rPr sz="900" b="0">
                 <a:solidFill>
-                  <a:srgbClr val="64748B"/>
+                  <a:srgbClr val="94A3B8"/>
                 </a:solidFill>
               </a:rPr>
               <a:t>in our dataset</a:t>
@@ -7274,12 +7019,12 @@
               </a:spcAft>
             </a:pPr>
             <a:r>
-              <a:rPr sz="1800" b="1">
-                <a:solidFill>
-                  <a:srgbClr val="0F172A"/>
-                </a:solidFill>
-              </a:rPr>
-              <a:t>50 %+ stations</a:t>
+              <a:rPr sz="2000" b="1">
+                <a:solidFill>
+                  <a:srgbClr val="FFFFFF"/>
+                </a:solidFill>
+              </a:rPr>
+              <a:t>50%+ stations</a:t>
             </a:r>
           </a:p>
           <a:p>
@@ -7294,10 +7039,10 @@
             <a:r>
               <a:rPr sz="900" b="0">
                 <a:solidFill>
-                  <a:srgbClr val="64748B"/>
-                </a:solidFill>
-              </a:rPr>
-              <a:t>at or above capacity</a:t>
+                  <a:srgbClr val="94A3B8"/>
+                </a:solidFill>
+              </a:rPr>
+              <a:t>at capacity</a:t>
             </a:r>
           </a:p>
         </p:txBody>
@@ -7374,7 +7119,7 @@
             <a:r>
               <a:rPr sz="1200" b="1">
                 <a:solidFill>
-                  <a:srgbClr val="2D7FF9"/>
+                  <a:srgbClr val="FF00BF"/>
                 </a:solidFill>
               </a:rPr>
               <a:t>Cost of Inaction</a:t>
@@ -7421,7 +7166,7 @@
             <a:r>
               <a:rPr sz="1000" b="1">
                 <a:solidFill>
-                  <a:srgbClr val="0F172A"/>
+                  <a:srgbClr val="FFFFFF"/>
                 </a:solidFill>
               </a:rPr>
               <a:t>Without expansion:</a:t>
@@ -7440,10 +7185,10 @@
             <a:r>
               <a:rPr sz="900" b="0">
                 <a:solidFill>
-                  <a:srgbClr val="64748B"/>
-                </a:solidFill>
-              </a:rPr>
-              <a:t>▸ Riders lost to competitors</a:t>
+                  <a:srgbClr val="94A3B8"/>
+                </a:solidFill>
+              </a:rPr>
+              <a:t>▸  Riders lost to competitors</a:t>
             </a:r>
           </a:p>
           <a:p>
@@ -7458,10 +7203,10 @@
             <a:r>
               <a:rPr sz="900" b="0">
                 <a:solidFill>
-                  <a:srgbClr val="64748B"/>
-                </a:solidFill>
-              </a:rPr>
-              <a:t>▸ $11.3 M/yr unrealized profit</a:t>
+                  <a:srgbClr val="94A3B8"/>
+                </a:solidFill>
+              </a:rPr>
+              <a:t>▸  $11.3M/yr unrealized profit</a:t>
             </a:r>
           </a:p>
           <a:p>
@@ -7476,28 +7221,10 @@
             <a:r>
               <a:rPr sz="900" b="0">
                 <a:solidFill>
-                  <a:srgbClr val="64748B"/>
-                </a:solidFill>
-              </a:rPr>
-              <a:t>▸ Underserved neighborhoods</a:t>
-            </a:r>
-          </a:p>
-          <a:p>
-            <a:pPr algn="l">
-              <a:spcBef>
-                <a:spcPts val="0"/>
-              </a:spcBef>
-              <a:spcAft>
-                <a:spcPts val="200"/>
-              </a:spcAft>
-            </a:pPr>
-            <a:r>
-              <a:rPr sz="900" b="0">
-                <a:solidFill>
-                  <a:srgbClr val="64748B"/>
-                </a:solidFill>
-              </a:rPr>
-              <a:t>▸ Compounding loss each year</a:t>
+                  <a:srgbClr val="94A3B8"/>
+                </a:solidFill>
+              </a:rPr>
+              <a:t>▸  Underserved neighborhoods</a:t>
             </a:r>
           </a:p>
         </p:txBody>
@@ -7684,7 +7411,7 @@
             <a:r>
               <a:rPr sz="1200" b="1">
                 <a:solidFill>
-                  <a:srgbClr val="2D7FF9"/>
+                  <a:srgbClr val="FFFFFF"/>
                 </a:solidFill>
               </a:rPr>
               <a:t>Project Goals</a:t>
@@ -7730,7 +7457,7 @@
             <a:r>
               <a:rPr sz="1100" b="0">
                 <a:solidFill>
-                  <a:srgbClr val="0F172A"/>
+                  <a:srgbClr val="FFFFFF"/>
                 </a:solidFill>
               </a:rPr>
               <a:t>1.  Build XGBoost demand forecast</a:t>
@@ -7743,13 +7470,13 @@
                 <a:spcPts val="0"/>
               </a:spcBef>
               <a:spcAft>
-                <a:spcPts val="400"/>
+                <a:spcPts val="300"/>
               </a:spcAft>
             </a:pPr>
             <a:r>
               <a:rPr sz="900" b="0">
                 <a:solidFill>
-                  <a:srgbClr val="64748B"/>
+                  <a:srgbClr val="94A3B8"/>
                 </a:solidFill>
               </a:rPr>
               <a:t>     Predict daily station-level trips</a:t>
@@ -7767,7 +7494,7 @@
             <a:r>
               <a:rPr sz="1100" b="0">
                 <a:solidFill>
-                  <a:srgbClr val="0F172A"/>
+                  <a:srgbClr val="FFFFFF"/>
                 </a:solidFill>
               </a:rPr>
               <a:t>2.  Identify expansion opportunities</a:t>
@@ -7779,13 +7506,13 @@
                 <a:spcPts val="0"/>
               </a:spcBef>
               <a:spcAft>
-                <a:spcPts val="400"/>
+                <a:spcPts val="300"/>
               </a:spcAft>
             </a:pPr>
             <a:r>
               <a:rPr sz="900" b="0">
                 <a:solidFill>
-                  <a:srgbClr val="64748B"/>
+                  <a:srgbClr val="94A3B8"/>
                 </a:solidFill>
               </a:rPr>
               <a:t>     MTA transit + bike demand scoring</a:t>
@@ -7803,7 +7530,7 @@
             <a:r>
               <a:rPr sz="1100" b="0">
                 <a:solidFill>
-                  <a:srgbClr val="0F172A"/>
+                  <a:srgbClr val="FFFFFF"/>
                 </a:solidFill>
               </a:rPr>
               <a:t>3.  Calculate expansion ROI</a:t>
@@ -7815,13 +7542,13 @@
                 <a:spcPts val="0"/>
               </a:spcBef>
               <a:spcAft>
-                <a:spcPts val="400"/>
+                <a:spcPts val="300"/>
               </a:spcAft>
             </a:pPr>
             <a:r>
               <a:rPr sz="900" b="0">
                 <a:solidFill>
-                  <a:srgbClr val="64748B"/>
+                  <a:srgbClr val="94A3B8"/>
                 </a:solidFill>
               </a:rPr>
               <a:t>     NPV, IRR, payback period</a:t>
@@ -7839,7 +7566,7 @@
             <a:r>
               <a:rPr sz="1100" b="0">
                 <a:solidFill>
-                  <a:srgbClr val="0F172A"/>
+                  <a:srgbClr val="FFFFFF"/>
                 </a:solidFill>
               </a:rPr>
               <a:t>4.  Build interactive dashboard</a:t>
@@ -7857,7 +7584,7 @@
             <a:r>
               <a:rPr sz="900" b="0">
                 <a:solidFill>
-                  <a:srgbClr val="64748B"/>
+                  <a:srgbClr val="94A3B8"/>
                 </a:solidFill>
               </a:rPr>
               <a:t>     For government decision-makers</a:t>
@@ -7932,7 +7659,7 @@
             <a:r>
               <a:rPr sz="1200" b="1">
                 <a:solidFill>
-                  <a:srgbClr val="2D7FF9"/>
+                  <a:srgbClr val="FF00BF"/>
                 </a:solidFill>
               </a:rPr>
               <a:t>Success Metrics</a:t>
@@ -7992,7 +7719,7 @@
                 <a:spcPts val="0"/>
               </a:spcBef>
               <a:spcAft>
-                <a:spcPts val="400"/>
+                <a:spcPts val="300"/>
               </a:spcAft>
             </a:pPr>
             <a:r>
@@ -8001,7 +7728,7 @@
                   <a:srgbClr val="10B981"/>
                 </a:solidFill>
               </a:rPr>
-              <a:t>  Achieved: 11.24 ✓</a:t>
+              <a:t>   Achieved: 11.24  ✓</a:t>
             </a:r>
           </a:p>
           <a:p>
@@ -8019,7 +7746,7 @@
                   <a:srgbClr val="0F172A"/>
                 </a:solidFill>
               </a:rPr>
-              <a:t>Beat baseline by &gt; 30 %</a:t>
+              <a:t>Beat baseline &gt; 30%</a:t>
             </a:r>
           </a:p>
           <a:p>
@@ -8028,7 +7755,7 @@
                 <a:spcPts val="0"/>
               </a:spcBef>
               <a:spcAft>
-                <a:spcPts val="400"/>
+                <a:spcPts val="300"/>
               </a:spcAft>
             </a:pPr>
             <a:r>
@@ -8037,7 +7764,7 @@
                   <a:srgbClr val="10B981"/>
                 </a:solidFill>
               </a:rPr>
-              <a:t>  Achieved: 42.5 % ✓</a:t>
+              <a:t>   Achieved: 42.5%  ✓</a:t>
             </a:r>
           </a:p>
           <a:p>
@@ -8073,7 +7800,7 @@
                   <a:srgbClr val="10B981"/>
                 </a:solidFill>
               </a:rPr>
-              <a:t>  Achieved: 9.35 ✓</a:t>
+              <a:t>   Achieved: 9.35  ✓</a:t>
             </a:r>
           </a:p>
         </p:txBody>
@@ -8120,10 +7847,10 @@
             <a:r>
               <a:rPr sz="1200" b="1">
                 <a:solidFill>
-                  <a:srgbClr val="2D7FF9"/>
-                </a:solidFill>
-              </a:rPr>
-              <a:t>Break-Even</a:t>
+                  <a:srgbClr val="FFFFFF"/>
+                </a:solidFill>
+              </a:rPr>
+              <a:t>Break-Even Analysis</a:t>
             </a:r>
           </a:p>
           <a:p>
@@ -8141,16 +7868,16 @@
                 <a:spcPts val="0"/>
               </a:spcBef>
               <a:spcAft>
-                <a:spcPts val="400"/>
+                <a:spcPts val="300"/>
               </a:spcAft>
             </a:pPr>
             <a:r>
               <a:rPr sz="1100" b="0">
                 <a:solidFill>
-                  <a:srgbClr val="0F172A"/>
-                </a:solidFill>
-              </a:rPr>
-              <a:t>250 stations × $128 K = $32 M</a:t>
+                  <a:srgbClr val="FFFFFF"/>
+                </a:solidFill>
+              </a:rPr>
+              <a:t>250 stations × $128K = $32M</a:t>
             </a:r>
           </a:p>
           <a:p>
@@ -8163,12 +7890,12 @@
               </a:spcAft>
             </a:pPr>
             <a:r>
-              <a:rPr sz="1300" b="1">
+              <a:rPr sz="1400" b="1">
                 <a:solidFill>
                   <a:srgbClr val="FF00BF"/>
                 </a:solidFill>
               </a:rPr>
-              <a:t>Net profit: $11.3 M/yr</a:t>
+              <a:t>Net profit: $11.3M/yr</a:t>
             </a:r>
           </a:p>
           <a:p>
@@ -8181,7 +7908,7 @@
               </a:spcAft>
             </a:pPr>
             <a:r>
-              <a:rPr sz="1300" b="1">
+              <a:rPr sz="1400" b="1">
                 <a:solidFill>
                   <a:srgbClr val="10B981"/>
                 </a:solidFill>
@@ -8403,7 +8130,7 @@
             <a:r>
               <a:rPr sz="1100" b="1">
                 <a:solidFill>
-                  <a:srgbClr val="2D7FF9"/>
+                  <a:srgbClr val="FF00BF"/>
                 </a:solidFill>
               </a:rPr>
               <a:t>Trip Data</a:t>
@@ -8450,7 +8177,7 @@
             <a:r>
               <a:rPr sz="900" b="1">
                 <a:solidFill>
-                  <a:srgbClr val="0F172A"/>
+                  <a:srgbClr val="FFFFFF"/>
                 </a:solidFill>
               </a:rPr>
               <a:t>Citi Bike trip records (2+ years)</a:t>
@@ -8469,28 +8196,10 @@
             <a:r>
               <a:rPr sz="800" b="0">
                 <a:solidFill>
-                  <a:srgbClr val="64748B"/>
-                </a:solidFill>
-              </a:rPr>
-              <a:t>60.9 M trips · start/end station</a:t>
-            </a:r>
-          </a:p>
-          <a:p>
-            <a:pPr algn="l">
-              <a:spcBef>
-                <a:spcPts val="0"/>
-              </a:spcBef>
-              <a:spcAft>
-                <a:spcPts val="200"/>
-              </a:spcAft>
-            </a:pPr>
-            <a:r>
-              <a:rPr sz="800" b="0">
-                <a:solidFill>
-                  <a:srgbClr val="64748B"/>
-                </a:solidFill>
-              </a:rPr>
-              <a:t>timestamp · rider type · bike type</a:t>
+                  <a:srgbClr val="94A3B8"/>
+                </a:solidFill>
+              </a:rPr>
+              <a:t>60.9M trips · station · timestamp · rider type</a:t>
             </a:r>
           </a:p>
         </p:txBody>
@@ -8561,7 +8270,7 @@
             <a:r>
               <a:rPr sz="1100" b="1">
                 <a:solidFill>
-                  <a:srgbClr val="2D7FF9"/>
+                  <a:srgbClr val="FF00BF"/>
                 </a:solidFill>
               </a:rPr>
               <a:t>Transit &amp; Weather</a:t>
@@ -8608,7 +8317,7 @@
             <a:r>
               <a:rPr sz="900" b="1">
                 <a:solidFill>
-                  <a:srgbClr val="0F172A"/>
+                  <a:srgbClr val="FFFFFF"/>
                 </a:solidFill>
               </a:rPr>
               <a:t>MTA subway ridership + delays</a:t>
@@ -8627,7 +8336,7 @@
             <a:r>
               <a:rPr sz="800" b="0">
                 <a:solidFill>
-                  <a:srgbClr val="64748B"/>
+                  <a:srgbClr val="94A3B8"/>
                 </a:solidFill>
               </a:rPr>
               <a:t>NOAA weather · NYC open data</a:t>
@@ -8701,7 +8410,7 @@
             <a:r>
               <a:rPr sz="1100" b="1">
                 <a:solidFill>
-                  <a:srgbClr val="2D7FF9"/>
+                  <a:srgbClr val="FF00BF"/>
                 </a:solidFill>
               </a:rPr>
               <a:t>Pricing &amp; Revenue</a:t>
@@ -8748,7 +8457,7 @@
             <a:r>
               <a:rPr sz="900" b="0">
                 <a:solidFill>
-                  <a:srgbClr val="0F172A"/>
+                  <a:srgbClr val="FFFFFF"/>
                 </a:solidFill>
               </a:rPr>
               <a:t>$239 annual / $4.49 single ride</a:t>
@@ -8767,28 +8476,10 @@
             <a:r>
               <a:rPr sz="800" b="0">
                 <a:solidFill>
-                  <a:srgbClr val="64748B"/>
-                </a:solidFill>
-              </a:rPr>
-              <a:t>$3.24 avg e-bike overage</a:t>
-            </a:r>
-          </a:p>
-          <a:p>
-            <a:pPr algn="l">
-              <a:spcBef>
-                <a:spcPts val="0"/>
-              </a:spcBef>
-              <a:spcAft>
-                <a:spcPts val="200"/>
-              </a:spcAft>
-            </a:pPr>
-            <a:r>
-              <a:rPr sz="800" b="0">
-                <a:solidFill>
-                  <a:srgbClr val="64748B"/>
-                </a:solidFill>
-              </a:rPr>
-              <a:t>$17.5 M Citi sponsorship</a:t>
+                  <a:srgbClr val="94A3B8"/>
+                </a:solidFill>
+              </a:rPr>
+              <a:t>$17.5M Citi sponsorship</a:t>
             </a:r>
           </a:p>
         </p:txBody>
@@ -8829,7 +8520,7 @@
             <a:r>
               <a:rPr sz="1100" b="1">
                 <a:solidFill>
-                  <a:srgbClr val="2D7FF9"/>
+                  <a:srgbClr val="FFFFFF"/>
                 </a:solidFill>
               </a:rPr>
               <a:t>Data Quality</a:t>
@@ -8876,10 +8567,10 @@
             <a:r>
               <a:rPr sz="900" b="0">
                 <a:solidFill>
-                  <a:srgbClr val="0F172A"/>
-                </a:solidFill>
-              </a:rPr>
-              <a:t>Dropped null stations (&lt; 0.1 %)</a:t>
+                  <a:srgbClr val="FFFFFF"/>
+                </a:solidFill>
+              </a:rPr>
+              <a:t>Null stations dropped (&lt;0.1%)</a:t>
             </a:r>
             <a:endParaRPr lang="en-US" sz="1300" dirty="0"/>
           </a:p>
@@ -8895,28 +8586,10 @@
             <a:r>
               <a:rPr sz="800" b="0">
                 <a:solidFill>
-                  <a:srgbClr val="64748B"/>
-                </a:solidFill>
-              </a:rPr>
-              <a:t>Imputed missing capacity</a:t>
-            </a:r>
-          </a:p>
-          <a:p>
-            <a:pPr algn="l">
-              <a:spcBef>
-                <a:spcPts val="0"/>
-              </a:spcBef>
-              <a:spcAft>
-                <a:spcPts val="200"/>
-              </a:spcAft>
-            </a:pPr>
-            <a:r>
-              <a:rPr sz="800" b="0">
-                <a:solidFill>
-                  <a:srgbClr val="64748B"/>
-                </a:solidFill>
-              </a:rPr>
-              <a:t>Forward-filled weather gaps ≤ 2 d</a:t>
+                  <a:srgbClr val="94A3B8"/>
+                </a:solidFill>
+              </a:rPr>
+              <a:t>Weather forward-filled ≤2 days</a:t>
             </a:r>
           </a:p>
         </p:txBody>
@@ -8957,7 +8630,7 @@
             <a:r>
               <a:rPr sz="1100" b="1">
                 <a:solidFill>
-                  <a:srgbClr val="2D7FF9"/>
+                  <a:srgbClr val="FFFFFF"/>
                 </a:solidFill>
               </a:rPr>
               <a:t>Feature Engineering</a:t>
@@ -9004,7 +8677,7 @@
             <a:r>
               <a:rPr sz="900" b="1">
                 <a:solidFill>
-                  <a:srgbClr val="0F172A"/>
+                  <a:srgbClr val="FFFFFF"/>
                 </a:solidFill>
               </a:rPr>
               <a:t>23 features engineered:</a:t>
@@ -9023,28 +8696,10 @@
             <a:r>
               <a:rPr sz="800" b="0">
                 <a:solidFill>
-                  <a:srgbClr val="64748B"/>
-                </a:solidFill>
-              </a:rPr>
-              <a:t>Temporal lags · rolling means</a:t>
-            </a:r>
-          </a:p>
-          <a:p>
-            <a:pPr algn="l">
-              <a:spcBef>
-                <a:spcPts val="0"/>
-              </a:spcBef>
-              <a:spcAft>
-                <a:spcPts val="200"/>
-              </a:spcAft>
-            </a:pPr>
-            <a:r>
-              <a:rPr sz="800" b="0">
-                <a:solidFill>
-                  <a:srgbClr val="64748B"/>
-                </a:solidFill>
-              </a:rPr>
-              <a:t>Weather deviations · MTA scores</a:t>
+                  <a:srgbClr val="94A3B8"/>
+                </a:solidFill>
+              </a:rPr>
+              <a:t>Lags · rolling means · weather · MTA scores</a:t>
             </a:r>
           </a:p>
         </p:txBody>
@@ -9289,7 +8944,7 @@
             <a:r>
               <a:rPr sz="1100" b="1">
                 <a:solidFill>
-                  <a:srgbClr val="2D7FF9"/>
+                  <a:srgbClr val="FF00BF"/>
                 </a:solidFill>
               </a:rPr>
               <a:t>Python / Pandas</a:t>
@@ -9336,30 +8991,12 @@
             <a:r>
               <a:rPr sz="900" b="0">
                 <a:solidFill>
-                  <a:srgbClr val="0F172A"/>
-                </a:solidFill>
-              </a:rPr>
-              <a:t>ETL pipeline &amp; feature engineering</a:t>
+                  <a:srgbClr val="94A3B8"/>
+                </a:solidFill>
+              </a:rPr>
+              <a:t>ETL pipeline · feature engineering · Parquet I/O</a:t>
             </a:r>
             <a:endParaRPr lang="en-US" sz="1250" dirty="0"/>
-          </a:p>
-          <a:p>
-            <a:pPr algn="l">
-              <a:spcBef>
-                <a:spcPts val="0"/>
-              </a:spcBef>
-              <a:spcAft>
-                <a:spcPts val="200"/>
-              </a:spcAft>
-            </a:pPr>
-            <a:r>
-              <a:rPr sz="800" b="0">
-                <a:solidFill>
-                  <a:srgbClr val="64748B"/>
-                </a:solidFill>
-              </a:rPr>
-              <a:t>Parquet for fast I/O</a:t>
-            </a:r>
           </a:p>
         </p:txBody>
       </p:sp>
@@ -9459,7 +9096,7 @@
             <a:r>
               <a:rPr sz="1100" b="1">
                 <a:solidFill>
-                  <a:srgbClr val="2D7FF9"/>
+                  <a:srgbClr val="FF00BF"/>
                 </a:solidFill>
               </a:rPr>
               <a:t>Streamlit / Plotly</a:t>
@@ -9506,30 +9143,12 @@
             <a:r>
               <a:rPr sz="900" b="0">
                 <a:solidFill>
-                  <a:srgbClr val="0F172A"/>
-                </a:solidFill>
-              </a:rPr>
-              <a:t>9-tab interactive dashboard</a:t>
+                  <a:srgbClr val="94A3B8"/>
+                </a:solidFill>
+              </a:rPr>
+              <a:t>9-tab interactive dashboard on Streamlit Cloud</a:t>
             </a:r>
             <a:endParaRPr lang="en-US" sz="1250" dirty="0"/>
-          </a:p>
-          <a:p>
-            <a:pPr algn="l">
-              <a:spcBef>
-                <a:spcPts val="0"/>
-              </a:spcBef>
-              <a:spcAft>
-                <a:spcPts val="200"/>
-              </a:spcAft>
-            </a:pPr>
-            <a:r>
-              <a:rPr sz="800" b="0">
-                <a:solidFill>
-                  <a:srgbClr val="64748B"/>
-                </a:solidFill>
-              </a:rPr>
-              <a:t>Deployed on Streamlit Cloud</a:t>
-            </a:r>
           </a:p>
         </p:txBody>
       </p:sp>
@@ -9629,7 +9248,7 @@
             <a:r>
               <a:rPr sz="1100" b="1">
                 <a:solidFill>
-                  <a:srgbClr val="2D7FF9"/>
+                  <a:srgbClr val="FF00BF"/>
                 </a:solidFill>
               </a:rPr>
               <a:t>XGBoost / scikit-learn</a:t>
@@ -9676,30 +9295,12 @@
             <a:r>
               <a:rPr sz="900" b="0">
                 <a:solidFill>
-                  <a:srgbClr val="0F172A"/>
-                </a:solidFill>
-              </a:rPr>
-              <a:t>Demand forecasting w/ early stopping</a:t>
+                  <a:srgbClr val="94A3B8"/>
+                </a:solidFill>
+              </a:rPr>
+              <a:t>Demand forecast · 3-fold time-series CV · early stopping</a:t>
             </a:r>
             <a:endParaRPr lang="en-US" sz="1250" dirty="0"/>
-          </a:p>
-          <a:p>
-            <a:pPr algn="l">
-              <a:spcBef>
-                <a:spcPts val="0"/>
-              </a:spcBef>
-              <a:spcAft>
-                <a:spcPts val="200"/>
-              </a:spcAft>
-            </a:pPr>
-            <a:r>
-              <a:rPr sz="800" b="0">
-                <a:solidFill>
-                  <a:srgbClr val="64748B"/>
-                </a:solidFill>
-              </a:rPr>
-              <a:t>3-fold time-series cross-validation</a:t>
-            </a:r>
           </a:p>
         </p:txBody>
       </p:sp>
@@ -9799,7 +9400,7 @@
             <a:r>
               <a:rPr sz="1100" b="1">
                 <a:solidFill>
-                  <a:srgbClr val="2D7FF9"/>
+                  <a:srgbClr val="FF00BF"/>
                 </a:solidFill>
               </a:rPr>
               <a:t>Financial Modeling</a:t>
@@ -9845,30 +9446,12 @@
             <a:r>
               <a:rPr sz="900" b="0">
                 <a:solidFill>
-                  <a:srgbClr val="0F172A"/>
-                </a:solidFill>
-              </a:rPr>
-              <a:t>NPV / IRR cash flow analysis</a:t>
+                  <a:srgbClr val="94A3B8"/>
+                </a:solidFill>
+              </a:rPr>
+              <a:t>NPV/IRR cash flow · MTA opportunity scoring</a:t>
             </a:r>
             <a:endParaRPr lang="en-US" sz="1250" dirty="0"/>
-          </a:p>
-          <a:p>
-            <a:pPr algn="l">
-              <a:spcBef>
-                <a:spcPts val="0"/>
-              </a:spcBef>
-              <a:spcAft>
-                <a:spcPts val="200"/>
-              </a:spcAft>
-            </a:pPr>
-            <a:r>
-              <a:rPr sz="800" b="0">
-                <a:solidFill>
-                  <a:srgbClr val="64748B"/>
-                </a:solidFill>
-              </a:rPr>
-              <a:t>MTA opportunity scoring</a:t>
-            </a:r>
           </a:p>
         </p:txBody>
       </p:sp>
@@ -10024,138 +9607,12 @@
               </a:spcAft>
             </a:pPr>
             <a:r>
-              <a:rPr sz="1400" b="1">
+              <a:rPr sz="1100" b="0">
                 <a:solidFill>
                   <a:srgbClr val="0F172A"/>
                 </a:solidFill>
               </a:rPr>
-              <a:t>Claude Code (Anthropic)</a:t>
-            </a:r>
-          </a:p>
-          <a:p>
-            <a:pPr algn="l">
-              <a:spcBef>
-                <a:spcPts val="0"/>
-              </a:spcBef>
-              <a:spcAft>
-                <a:spcPts val="600"/>
-              </a:spcAft>
-            </a:pPr>
-            <a:r>
-              <a:rPr sz="1100" b="0">
-                <a:solidFill>
-                  <a:srgbClr val="2D7FF9"/>
-                </a:solidFill>
-              </a:rPr>
-              <a:t>AI pair-programmer</a:t>
-            </a:r>
-          </a:p>
-          <a:p>
-            <a:pPr algn="l">
-              <a:spcBef>
-                <a:spcPts val="0"/>
-              </a:spcBef>
-              <a:spcAft>
-                <a:spcPts val="200"/>
-              </a:spcAft>
-            </a:pPr>
-            <a:r>
-              <a:rPr sz="1000" b="0">
-                <a:solidFill>
-                  <a:srgbClr val="0F172A"/>
-                </a:solidFill>
-              </a:rPr>
-              <a:t>▸ Code generation — dashboard, charts, CSS</a:t>
-            </a:r>
-          </a:p>
-          <a:p>
-            <a:pPr algn="l">
-              <a:spcBef>
-                <a:spcPts val="0"/>
-              </a:spcBef>
-              <a:spcAft>
-                <a:spcPts val="200"/>
-              </a:spcAft>
-            </a:pPr>
-            <a:r>
-              <a:rPr sz="1000" b="0">
-                <a:solidFill>
-                  <a:srgbClr val="0F172A"/>
-                </a:solidFill>
-              </a:rPr>
-              <a:t>▸ Model iteration — XGBoost tuning, features</a:t>
-            </a:r>
-          </a:p>
-          <a:p>
-            <a:pPr algn="l">
-              <a:spcBef>
-                <a:spcPts val="0"/>
-              </a:spcBef>
-              <a:spcAft>
-                <a:spcPts val="200"/>
-              </a:spcAft>
-            </a:pPr>
-            <a:r>
-              <a:rPr sz="1000" b="0">
-                <a:solidFill>
-                  <a:srgbClr val="0F172A"/>
-                </a:solidFill>
-              </a:rPr>
-              <a:t>▸ Data pipeline — ETL, revenue, MTA integration</a:t>
-            </a:r>
-          </a:p>
-          <a:p>
-            <a:pPr algn="l">
-              <a:spcBef>
-                <a:spcPts val="0"/>
-              </a:spcBef>
-              <a:spcAft>
-                <a:spcPts val="200"/>
-              </a:spcAft>
-            </a:pPr>
-            <a:r>
-              <a:rPr sz="1000" b="0">
-                <a:solidFill>
-                  <a:srgbClr val="0F172A"/>
-                </a:solidFill>
-              </a:rPr>
-              <a:t>▸ Optimization — caching &amp; fragment decorators</a:t>
-            </a:r>
-          </a:p>
-          <a:p>
-            <a:pPr algn="l">
-              <a:spcBef>
-                <a:spcPts val="0"/>
-              </a:spcBef>
-              <a:spcAft>
-                <a:spcPts val="200"/>
-              </a:spcAft>
-            </a:pPr>
-            <a:r>
-              <a:rPr sz="600" b="0">
-                <a:solidFill>
-                  <a:srgbClr val="0F172A"/>
-                </a:solidFill>
-              </a:rPr>
-              <a:t/>
-            </a:r>
-          </a:p>
-          <a:p>
-            <a:pPr algn="l">
-              <a:spcBef>
-                <a:spcPts val="0"/>
-              </a:spcBef>
-              <a:spcAft>
-                <a:spcPts val="200"/>
-              </a:spcAft>
-            </a:pPr>
-            <a:r>
-              <a:rPr sz="900" b="0">
-                <a:solidFill>
-                  <a:srgbClr val="64748B"/>
-                </a:solidFill>
-              </a:rPr>
-              <a:t>All code reviewed &amp; stress-tested. Every commit co-authored.</a:t>
+              <a:t>How we used AI as a pair-programmer across the full project lifecycle.</a:t>
             </a:r>
           </a:p>
         </p:txBody>
@@ -10480,6 +9937,314 @@
           </a:prstGeom>
         </p:spPr>
       </p:pic>
+      <p:sp>
+        <p:nvSpPr>
+          <p:cNvPr id="20" name="TextBox 19"/>
+          <p:cNvSpPr txBox="1"/>
+          <p:nvPr/>
+        </p:nvSpPr>
+        <p:spPr>
+          <a:xfrm>
+            <a:off x="914400" y="1828800"/>
+            <a:ext cx="4754880" cy="1463040"/>
+          </a:xfrm>
+          <a:prstGeom prst="rect">
+            <a:avLst/>
+          </a:prstGeom>
+          <a:noFill/>
+        </p:spPr>
+        <p:txBody>
+          <a:bodyPr wrap="square">
+            <a:spAutoFit/>
+          </a:bodyPr>
+          <a:lstStyle/>
+          <a:p>
+            <a:pPr algn="l">
+              <a:spcBef>
+                <a:spcPts val="0"/>
+              </a:spcBef>
+              <a:spcAft>
+                <a:spcPts val="200"/>
+              </a:spcAft>
+            </a:pPr>
+            <a:r>
+              <a:rPr sz="1400" b="1">
+                <a:solidFill>
+                  <a:srgbClr val="FFFFFF"/>
+                </a:solidFill>
+              </a:rPr>
+              <a:t>Claude Code (Anthropic)</a:t>
+            </a:r>
+          </a:p>
+          <a:p>
+            <a:pPr algn="l">
+              <a:spcBef>
+                <a:spcPts val="0"/>
+              </a:spcBef>
+              <a:spcAft>
+                <a:spcPts val="200"/>
+              </a:spcAft>
+            </a:pPr>
+            <a:r>
+              <a:rPr sz="1000" b="0">
+                <a:solidFill>
+                  <a:srgbClr val="94A3B8"/>
+                </a:solidFill>
+              </a:rPr>
+              <a:t>AI pair-programmer for dashboard,</a:t>
+            </a:r>
+          </a:p>
+          <a:p>
+            <a:pPr algn="l">
+              <a:spcBef>
+                <a:spcPts val="0"/>
+              </a:spcBef>
+              <a:spcAft>
+                <a:spcPts val="200"/>
+              </a:spcAft>
+            </a:pPr>
+            <a:r>
+              <a:rPr sz="1000" b="0">
+                <a:solidFill>
+                  <a:srgbClr val="94A3B8"/>
+                </a:solidFill>
+              </a:rPr>
+              <a:t>modeling, ETL, and optimization.</a:t>
+            </a:r>
+          </a:p>
+        </p:txBody>
+      </p:sp>
+      <p:sp>
+        <p:nvSpPr>
+          <p:cNvPr id="21" name="TextBox 20"/>
+          <p:cNvSpPr txBox="1"/>
+          <p:nvPr/>
+        </p:nvSpPr>
+        <p:spPr>
+          <a:xfrm>
+            <a:off x="6492240" y="1828800"/>
+            <a:ext cx="4754880" cy="1463040"/>
+          </a:xfrm>
+          <a:prstGeom prst="rect">
+            <a:avLst/>
+          </a:prstGeom>
+          <a:noFill/>
+        </p:spPr>
+        <p:txBody>
+          <a:bodyPr wrap="square">
+            <a:spAutoFit/>
+          </a:bodyPr>
+          <a:lstStyle/>
+          <a:p>
+            <a:pPr algn="l">
+              <a:spcBef>
+                <a:spcPts val="0"/>
+              </a:spcBef>
+              <a:spcAft>
+                <a:spcPts val="200"/>
+              </a:spcAft>
+            </a:pPr>
+            <a:r>
+              <a:rPr sz="1400" b="1">
+                <a:solidFill>
+                  <a:srgbClr val="FFFFFF"/>
+                </a:solidFill>
+              </a:rPr>
+              <a:t>Dashboard Development</a:t>
+            </a:r>
+          </a:p>
+          <a:p>
+            <a:pPr algn="l">
+              <a:spcBef>
+                <a:spcPts val="0"/>
+              </a:spcBef>
+              <a:spcAft>
+                <a:spcPts val="200"/>
+              </a:spcAft>
+            </a:pPr>
+            <a:r>
+              <a:rPr sz="1000" b="0">
+                <a:solidFill>
+                  <a:srgbClr val="94A3B8"/>
+                </a:solidFill>
+              </a:rPr>
+              <a:t>9-tab Streamlit app with Plotly</a:t>
+            </a:r>
+          </a:p>
+          <a:p>
+            <a:pPr algn="l">
+              <a:spcBef>
+                <a:spcPts val="0"/>
+              </a:spcBef>
+              <a:spcAft>
+                <a:spcPts val="200"/>
+              </a:spcAft>
+            </a:pPr>
+            <a:r>
+              <a:rPr sz="1000" b="0">
+                <a:solidFill>
+                  <a:srgbClr val="94A3B8"/>
+                </a:solidFill>
+              </a:rPr>
+              <a:t>charts, maps, and interactive filters.</a:t>
+            </a:r>
+          </a:p>
+        </p:txBody>
+      </p:sp>
+      <p:sp>
+        <p:nvSpPr>
+          <p:cNvPr id="22" name="TextBox 21"/>
+          <p:cNvSpPr txBox="1"/>
+          <p:nvPr/>
+        </p:nvSpPr>
+        <p:spPr>
+          <a:xfrm>
+            <a:off x="914400" y="3931920"/>
+            <a:ext cx="4754880" cy="1463040"/>
+          </a:xfrm>
+          <a:prstGeom prst="rect">
+            <a:avLst/>
+          </a:prstGeom>
+          <a:noFill/>
+        </p:spPr>
+        <p:txBody>
+          <a:bodyPr wrap="square">
+            <a:spAutoFit/>
+          </a:bodyPr>
+          <a:lstStyle/>
+          <a:p>
+            <a:pPr algn="l">
+              <a:spcBef>
+                <a:spcPts val="0"/>
+              </a:spcBef>
+              <a:spcAft>
+                <a:spcPts val="200"/>
+              </a:spcAft>
+            </a:pPr>
+            <a:r>
+              <a:rPr sz="1400" b="1">
+                <a:solidFill>
+                  <a:srgbClr val="FFFFFF"/>
+                </a:solidFill>
+              </a:rPr>
+              <a:t>XGBoost Modeling</a:t>
+            </a:r>
+          </a:p>
+          <a:p>
+            <a:pPr algn="l">
+              <a:spcBef>
+                <a:spcPts val="0"/>
+              </a:spcBef>
+              <a:spcAft>
+                <a:spcPts val="200"/>
+              </a:spcAft>
+            </a:pPr>
+            <a:r>
+              <a:rPr sz="1000" b="0">
+                <a:solidFill>
+                  <a:srgbClr val="94A3B8"/>
+                </a:solidFill>
+              </a:rPr>
+              <a:t>Feature engineering, hyperparameter</a:t>
+            </a:r>
+          </a:p>
+          <a:p>
+            <a:pPr algn="l">
+              <a:spcBef>
+                <a:spcPts val="0"/>
+              </a:spcBef>
+              <a:spcAft>
+                <a:spcPts val="200"/>
+              </a:spcAft>
+            </a:pPr>
+            <a:r>
+              <a:rPr sz="1000" b="0">
+                <a:solidFill>
+                  <a:srgbClr val="94A3B8"/>
+                </a:solidFill>
+              </a:rPr>
+              <a:t>tuning, 3-fold time-series CV.</a:t>
+            </a:r>
+          </a:p>
+        </p:txBody>
+      </p:sp>
+      <p:sp>
+        <p:nvSpPr>
+          <p:cNvPr id="23" name="TextBox 22"/>
+          <p:cNvSpPr txBox="1"/>
+          <p:nvPr/>
+        </p:nvSpPr>
+        <p:spPr>
+          <a:xfrm>
+            <a:off x="6492240" y="3931920"/>
+            <a:ext cx="4754880" cy="1463040"/>
+          </a:xfrm>
+          <a:prstGeom prst="rect">
+            <a:avLst/>
+          </a:prstGeom>
+          <a:noFill/>
+        </p:spPr>
+        <p:txBody>
+          <a:bodyPr wrap="square">
+            <a:spAutoFit/>
+          </a:bodyPr>
+          <a:lstStyle/>
+          <a:p>
+            <a:pPr algn="l">
+              <a:spcBef>
+                <a:spcPts val="0"/>
+              </a:spcBef>
+              <a:spcAft>
+                <a:spcPts val="200"/>
+              </a:spcAft>
+            </a:pPr>
+            <a:r>
+              <a:rPr sz="1400" b="1">
+                <a:solidFill>
+                  <a:srgbClr val="FFFFFF"/>
+                </a:solidFill>
+              </a:rPr>
+              <a:t>Code Review &amp; Testing</a:t>
+            </a:r>
+          </a:p>
+          <a:p>
+            <a:pPr algn="l">
+              <a:spcBef>
+                <a:spcPts val="0"/>
+              </a:spcBef>
+              <a:spcAft>
+                <a:spcPts val="200"/>
+              </a:spcAft>
+            </a:pPr>
+            <a:r>
+              <a:rPr sz="1000" b="0">
+                <a:solidFill>
+                  <a:srgbClr val="94A3B8"/>
+                </a:solidFill>
+              </a:rPr>
+              <a:t>All code reviewed, stress-tested,</a:t>
+            </a:r>
+          </a:p>
+          <a:p>
+            <a:pPr algn="l">
+              <a:spcBef>
+                <a:spcPts val="0"/>
+              </a:spcBef>
+              <a:spcAft>
+                <a:spcPts val="200"/>
+              </a:spcAft>
+            </a:pPr>
+            <a:r>
+              <a:rPr sz="1000" b="0">
+                <a:solidFill>
+                  <a:srgbClr val="94A3B8"/>
+                </a:solidFill>
+              </a:rPr>
+              <a:t>and co-authored by the team.</a:t>
+            </a:r>
+          </a:p>
+        </p:txBody>
+      </p:sp>
     </p:spTree>
     <p:extLst>
       <p:ext uri="{BB962C8B-B14F-4D97-AF65-F5344CB8AC3E}">
@@ -10589,10 +10354,10 @@
             <a:r>
               <a:rPr sz="1100" b="0">
                 <a:solidFill>
-                  <a:srgbClr val="64748B"/>
-                </a:solidFill>
-              </a:rPr>
-              <a:t>Key patterns from 60.9 M Citi Bike trips.</a:t>
+                  <a:srgbClr val="94A3B8"/>
+                </a:solidFill>
+              </a:rPr>
+              <a:t>Patterns from 60.9M trips across 2,476 stations.</a:t>
             </a:r>
             <a:endParaRPr lang="en-US" sz="1250" dirty="0"/>
           </a:p>
@@ -10674,86 +10439,14 @@
               <a:buNone/>
             </a:pPr>
             <a:r>
-              <a:rPr sz="1100" b="0">
+              <a:rPr sz="100" b="0">
                 <a:solidFill>
                   <a:srgbClr val="0F172A"/>
                 </a:solidFill>
               </a:rPr>
-              <a:t>▸ Weekday demand 40 % &gt; weekends</a:t>
+              <a:t/>
             </a:r>
             <a:endParaRPr lang="en-US" sz="1250" dirty="0"/>
-          </a:p>
-          <a:p>
-            <a:pPr algn="l">
-              <a:spcBef>
-                <a:spcPts val="0"/>
-              </a:spcBef>
-              <a:spcAft>
-                <a:spcPts val="200"/>
-              </a:spcAft>
-            </a:pPr>
-            <a:r>
-              <a:rPr sz="1100" b="0">
-                <a:solidFill>
-                  <a:srgbClr val="0F172A"/>
-                </a:solidFill>
-              </a:rPr>
-              <a:t>▸ Peak hours: 8 AM + 5–6 PM</a:t>
-            </a:r>
-          </a:p>
-          <a:p>
-            <a:pPr algn="l">
-              <a:spcBef>
-                <a:spcPts val="0"/>
-              </a:spcBef>
-              <a:spcAft>
-                <a:spcPts val="200"/>
-              </a:spcAft>
-            </a:pPr>
-            <a:r>
-              <a:rPr sz="1100" b="0">
-                <a:solidFill>
-                  <a:srgbClr val="0F172A"/>
-                </a:solidFill>
-              </a:rPr>
-              <a:t>▸ Subway delays → 2.3× bike usage</a:t>
-            </a:r>
-          </a:p>
-          <a:p>
-            <a:pPr algn="l">
-              <a:spcBef>
-                <a:spcPts val="0"/>
-              </a:spcBef>
-              <a:spcAft>
-                <a:spcPts val="200"/>
-              </a:spcAft>
-            </a:pPr>
-            <a:r>
-              <a:rPr sz="1100" b="0">
-                <a:solidFill>
-                  <a:srgbClr val="0F172A"/>
-                </a:solidFill>
-              </a:rPr>
-              <a:t>▸ Summer = 3× winter demand</a:t>
-            </a:r>
-          </a:p>
-          <a:p>
-            <a:pPr algn="l">
-              <a:spcBef>
-                <a:spcPts val="0"/>
-              </a:spcBef>
-              <a:spcAft>
-                <a:spcPts val="200"/>
-              </a:spcAft>
-            </a:pPr>
-            <a:r>
-              <a:rPr sz="1100" b="0">
-                <a:solidFill>
-                  <a:srgbClr val="0F172A"/>
-                </a:solidFill>
-              </a:rPr>
-              <a:t>▸ E-bike share growing rapidly</a:t>
-            </a:r>
           </a:p>
         </p:txBody>
       </p:sp>
@@ -10831,7 +10524,7 @@
                   <a:srgbClr val="FF00BF"/>
                 </a:solidFill>
               </a:rPr>
-              <a:t>50 %+</a:t>
+              <a:t>50%+</a:t>
             </a:r>
             <a:endParaRPr lang="en-US" sz="3200" dirty="0"/>
           </a:p>
@@ -10881,10 +10574,10 @@
             <a:r>
               <a:rPr sz="900" b="0">
                 <a:solidFill>
-                  <a:srgbClr val="64748B"/>
-                </a:solidFill>
-              </a:rPr>
-              <a:t>stations maxed out</a:t>
+                  <a:srgbClr val="FFFFFF"/>
+                </a:solidFill>
+              </a:rPr>
+              <a:t>stations at capacity</a:t>
             </a:r>
           </a:p>
         </p:txBody>
@@ -10934,7 +10627,7 @@
                   <a:srgbClr val="2D7FF9"/>
                 </a:solidFill>
               </a:rPr>
-              <a:t>$196 M</a:t>
+              <a:t>$196M</a:t>
             </a:r>
             <a:endParaRPr lang="en-US" sz="3200" dirty="0"/>
           </a:p>
@@ -10984,7 +10677,7 @@
             <a:r>
               <a:rPr sz="900" b="0">
                 <a:solidFill>
-                  <a:srgbClr val="64748B"/>
+                  <a:srgbClr val="FFFFFF"/>
                 </a:solidFill>
               </a:rPr>
               <a:t>annual revenue</a:t>
@@ -11034,7 +10727,7 @@
                   <a:srgbClr val="10B981"/>
                 </a:solidFill>
               </a:rPr>
-              <a:t>42.5 %</a:t>
+              <a:t>42.5%</a:t>
             </a:r>
           </a:p>
           <a:p/>
@@ -11044,13 +10737,13 @@
                 <a:spcPts val="0"/>
               </a:spcBef>
               <a:spcAft>
-                <a:spcPts val="800"/>
+                <a:spcPts val="600"/>
               </a:spcAft>
             </a:pPr>
             <a:r>
               <a:rPr sz="900" b="0">
                 <a:solidFill>
-                  <a:srgbClr val="64748B"/>
+                  <a:srgbClr val="FFFFFF"/>
                 </a:solidFill>
               </a:rPr>
               <a:t>better than baseline</a:t>
@@ -11086,7 +10779,7 @@
             <a:r>
               <a:rPr sz="900" b="0">
                 <a:solidFill>
-                  <a:srgbClr val="64748B"/>
+                  <a:srgbClr val="FFFFFF"/>
                 </a:solidFill>
               </a:rPr>
               <a:t>prediction correlation</a:t>
@@ -11120,6 +10813,30 @@
           <a:xfrm>
             <a:off x="11341993" y="6007993"/>
             <a:ext cx="850007" cy="850007"/>
+          </a:xfrm>
+          <a:prstGeom prst="rect">
+            <a:avLst/>
+          </a:prstGeom>
+        </p:spPr>
+      </p:pic>
+      <p:pic>
+        <p:nvPicPr>
+          <p:cNvPr id="22" name="Picture 21" descr="heatmap.png"/>
+          <p:cNvPicPr>
+            <a:picLocks noChangeAspect="1"/>
+          </p:cNvPicPr>
+          <p:nvPr/>
+        </p:nvPicPr>
+        <p:blipFill>
+          <a:blip r:embed="rId4"/>
+          <a:stretch>
+            <a:fillRect/>
+          </a:stretch>
+        </p:blipFill>
+        <p:spPr>
+          <a:xfrm>
+            <a:off x="640080" y="2743200"/>
+            <a:ext cx="4846320" cy="2468880"/>
           </a:xfrm>
           <a:prstGeom prst="rect">
             <a:avLst/>

</xml_diff>